<commit_message>
Add NovaCart case overview slide
</commit_message>
<xml_diff>
--- a/final/exports/novacart_investment_presentation.pptx
+++ b/final/exports/novacart_investment_presentation.pptx
@@ -2,18 +2,19 @@
 <file path=ppt/presentation.xml><?xml version="1.0" encoding="utf-8"?>
 <p:presentation xmlns:p="http://schemas.openxmlformats.org/presentationml/2006/main">
   <p:sldMasterIdLst>
-    <p:sldMasterId xmlns:r="http://schemas.openxmlformats.org/officeDocument/2006/relationships" id="2147483648" r:id="Rf74258133fd44761"/>
+    <p:sldMasterId xmlns:r="http://schemas.openxmlformats.org/officeDocument/2006/relationships" id="2147483648" r:id="R319ecbaa98ce408a"/>
   </p:sldMasterIdLst>
   <p:notesMasterIdLst>
-    <p:notesMasterId xmlns:r="http://schemas.openxmlformats.org/officeDocument/2006/relationships" r:id="R305c98fbe95a4b35"/>
+    <p:notesMasterId xmlns:r="http://schemas.openxmlformats.org/officeDocument/2006/relationships" r:id="R9b5c37d0747843f3"/>
   </p:notesMasterIdLst>
   <p:sldIdLst>
-    <p:sldId xmlns:r="http://schemas.openxmlformats.org/officeDocument/2006/relationships" id="256" r:id="R764a134dea7c4ded"/>
-    <p:sldId xmlns:r="http://schemas.openxmlformats.org/officeDocument/2006/relationships" id="257" r:id="Ra042970bf8684b21"/>
-    <p:sldId xmlns:r="http://schemas.openxmlformats.org/officeDocument/2006/relationships" id="258" r:id="Rfc392e39dea14ca6"/>
-    <p:sldId xmlns:r="http://schemas.openxmlformats.org/officeDocument/2006/relationships" id="259" r:id="Rd17efe40c2de4644"/>
-    <p:sldId xmlns:r="http://schemas.openxmlformats.org/officeDocument/2006/relationships" id="260" r:id="Re4f9ca264075487e"/>
-    <p:sldId xmlns:r="http://schemas.openxmlformats.org/officeDocument/2006/relationships" id="261" r:id="R8188555043094b94"/>
+    <p:sldId xmlns:r="http://schemas.openxmlformats.org/officeDocument/2006/relationships" id="256" r:id="R97af59b331fb4d5f"/>
+    <p:sldId xmlns:r="http://schemas.openxmlformats.org/officeDocument/2006/relationships" id="257" r:id="R9a4086fa68bb464b"/>
+    <p:sldId xmlns:r="http://schemas.openxmlformats.org/officeDocument/2006/relationships" id="258" r:id="R32516219f0bf4239"/>
+    <p:sldId xmlns:r="http://schemas.openxmlformats.org/officeDocument/2006/relationships" id="259" r:id="R6a50cd10b6054a78"/>
+    <p:sldId xmlns:r="http://schemas.openxmlformats.org/officeDocument/2006/relationships" id="260" r:id="Reb54906b26de4b0f"/>
+    <p:sldId xmlns:r="http://schemas.openxmlformats.org/officeDocument/2006/relationships" id="261" r:id="Rf3d890d696a14d3a"/>
+    <p:sldId xmlns:r="http://schemas.openxmlformats.org/officeDocument/2006/relationships" id="262" r:id="R277f9e3ed5d440f9"/>
   </p:sldIdLst>
   <p:sldSz cx="12192000" cy="6858000"/>
   <p:notesSz cx="6858000" cy="9144000"/>
@@ -447,6 +448,81 @@
           <a:lstStyle xmlns:a="http://schemas.openxmlformats.org/drawingml/2006/main"/>
           <a:p xmlns:a="http://schemas.openxmlformats.org/drawingml/2006/main">
             <a:r>
+              <a:t>Introduce NovaCart as a Northeast Ohio grocery delivery business serving households and small businesses. The April 6, 2026 case brief asks for $500,000 to expand delivery coverage and acquire customers. The revenue, active-customer and profitability figures on this slide are management claims as presented in the brief. The committee will assess whether the underlying records support the request.</a:t>
+            </a:r>
+          </a:p>
+          <a:p xmlns:a="http://schemas.openxmlformats.org/drawingml/2006/main">
+            <a:r>
+              <a:t>Source: inputs/claims.md.</a:t>
+            </a:r>
+          </a:p>
+        </p:txBody>
+      </p:sp>
+      <p:sp>
+        <p:nvSpPr>
+          <p:cNvPr id="4" name="Slide Number Placeholder 3"/>
+          <p:cNvSpPr>
+            <a:spLocks xmlns:a="http://schemas.openxmlformats.org/drawingml/2006/main" noGrp="1"/>
+          </p:cNvSpPr>
+          <p:nvPr>
+            <p:ph type="sldNum" idx="5"/>
+          </p:nvPr>
+        </p:nvSpPr>
+        <p:spPr/>
+        <p:txBody>
+          <a:bodyPr xmlns:a="http://schemas.openxmlformats.org/drawingml/2006/main"/>
+          <a:lstStyle xmlns:a="http://schemas.openxmlformats.org/drawingml/2006/main"/>
+          <a:p xmlns:a="http://schemas.openxmlformats.org/drawingml/2006/main"/>
+        </p:txBody>
+      </p:sp>
+    </p:spTree>
+  </p:cSld>
+  <p:clrMapOvr>
+    <a:masterClrMapping xmlns:a="http://schemas.openxmlformats.org/drawingml/2006/main"/>
+  </p:clrMapOvr>
+</p:notes>
+</file>
+
+<file path=ppt/notesSlides/notesSlide2.xml><?xml version="1.0" encoding="utf-8"?>
+<p:notes xmlns:p="http://schemas.openxmlformats.org/presentationml/2006/main">
+  <p:cSld>
+    <p:spTree>
+      <p:nvGrpSpPr>
+        <p:cNvPr id="1" name=""/>
+        <p:cNvGrpSpPr/>
+        <p:nvPr/>
+      </p:nvGrpSpPr>
+      <p:grpSpPr>
+        <a:xfrm xmlns:a="http://schemas.openxmlformats.org/drawingml/2006/main"/>
+      </p:grpSpPr>
+      <p:sp>
+        <p:nvSpPr>
+          <p:cNvPr id="2" name="Slide Image Placeholder 1"/>
+          <p:cNvSpPr>
+            <a:spLocks xmlns:a="http://schemas.openxmlformats.org/drawingml/2006/main" noGrp="1"/>
+          </p:cNvSpPr>
+          <p:nvPr>
+            <p:ph type="sldImg" idx="0"/>
+          </p:nvPr>
+        </p:nvSpPr>
+        <p:spPr/>
+      </p:sp>
+      <p:sp>
+        <p:nvSpPr>
+          <p:cNvPr id="3" name="Notes Placeholder 2"/>
+          <p:cNvSpPr>
+            <a:spLocks xmlns:a="http://schemas.openxmlformats.org/drawingml/2006/main" noGrp="1"/>
+          </p:cNvSpPr>
+          <p:nvPr>
+            <p:ph type="body" idx="1"/>
+          </p:nvPr>
+        </p:nvSpPr>
+        <p:spPr/>
+        <p:txBody>
+          <a:bodyPr xmlns:a="http://schemas.openxmlformats.org/drawingml/2006/main"/>
+          <a:lstStyle xmlns:a="http://schemas.openxmlformats.org/drawingml/2006/main"/>
+          <a:p xmlns:a="http://schemas.openxmlformats.org/drawingml/2006/main">
+            <a:r>
               <a:t>Decision: pass on the current $500,000 request as presented. The 2025 revenue, loss and cash forecast use the supplied claims, invoice and bank records. The base cash case excludes new financing and removes a $40,000 collection of a 2025 invoice from recurring receipts.</a:t>
             </a:r>
           </a:p>
@@ -482,7 +558,7 @@
 </p:notes>
 </file>
 
-<file path=ppt/notesSlides/notesSlide2.xml><?xml version="1.0" encoding="utf-8"?>
+<file path=ppt/notesSlides/notesSlide3.xml><?xml version="1.0" encoding="utf-8"?>
 <p:notes xmlns:p="http://schemas.openxmlformats.org/presentationml/2006/main">
   <p:cSld>
     <p:spTree>
@@ -557,7 +633,7 @@
 </p:notes>
 </file>
 
-<file path=ppt/notesSlides/notesSlide3.xml><?xml version="1.0" encoding="utf-8"?>
+<file path=ppt/notesSlides/notesSlide4.xml><?xml version="1.0" encoding="utf-8"?>
 <p:notes xmlns:p="http://schemas.openxmlformats.org/presentationml/2006/main">
   <p:cSld>
     <p:spTree>
@@ -632,7 +708,7 @@
 </p:notes>
 </file>
 
-<file path=ppt/notesSlides/notesSlide4.xml><?xml version="1.0" encoding="utf-8"?>
+<file path=ppt/notesSlides/notesSlide5.xml><?xml version="1.0" encoding="utf-8"?>
 <p:notes xmlns:p="http://schemas.openxmlformats.org/presentationml/2006/main">
   <p:cSld>
     <p:spTree>
@@ -707,7 +783,7 @@
 </p:notes>
 </file>
 
-<file path=ppt/notesSlides/notesSlide5.xml><?xml version="1.0" encoding="utf-8"?>
+<file path=ppt/notesSlides/notesSlide6.xml><?xml version="1.0" encoding="utf-8"?>
 <p:notes xmlns:p="http://schemas.openxmlformats.org/presentationml/2006/main">
   <p:cSld>
     <p:spTree>
@@ -782,7 +858,7 @@
 </p:notes>
 </file>
 
-<file path=ppt/notesSlides/notesSlide6.xml><?xml version="1.0" encoding="utf-8"?>
+<file path=ppt/notesSlides/notesSlide7.xml><?xml version="1.0" encoding="utf-8"?>
 <p:notes xmlns:p="http://schemas.openxmlformats.org/presentationml/2006/main">
   <p:cSld>
     <p:spTree>
@@ -3305,12 +3381,12 @@
   </p:cSld>
   <p:clrMap bg1="lt1" tx1="dk1" bg2="lt2" tx2="dk2" accent1="accent1" accent2="accent2" accent3="accent3" accent4="accent4" accent5="accent5" accent6="accent6" hlink="hlink" folHlink="folHlink"/>
   <p:sldLayoutIdLst>
-    <p:sldLayoutId xmlns:r="http://schemas.openxmlformats.org/officeDocument/2006/relationships" id="2147483649" r:id="Rf51c363b22fd4198"/>
-    <p:sldLayoutId xmlns:r="http://schemas.openxmlformats.org/officeDocument/2006/relationships" id="2147483650" r:id="Rebc688ecfdae47cb"/>
-    <p:sldLayoutId xmlns:r="http://schemas.openxmlformats.org/officeDocument/2006/relationships" id="2147483651" r:id="Rc8c6aa98bc084ea8"/>
-    <p:sldLayoutId xmlns:r="http://schemas.openxmlformats.org/officeDocument/2006/relationships" id="2147483652" r:id="Rc5bad2ef6ea94e32"/>
-    <p:sldLayoutId xmlns:r="http://schemas.openxmlformats.org/officeDocument/2006/relationships" id="2147483653" r:id="R6df0be22552c4052"/>
-    <p:sldLayoutId xmlns:r="http://schemas.openxmlformats.org/officeDocument/2006/relationships" id="2147483654" r:id="R60d64d5dd3ad432e"/>
+    <p:sldLayoutId xmlns:r="http://schemas.openxmlformats.org/officeDocument/2006/relationships" id="2147483649" r:id="R9199e09c76334c13"/>
+    <p:sldLayoutId xmlns:r="http://schemas.openxmlformats.org/officeDocument/2006/relationships" id="2147483650" r:id="Rd2958d5c2f434e2b"/>
+    <p:sldLayoutId xmlns:r="http://schemas.openxmlformats.org/officeDocument/2006/relationships" id="2147483651" r:id="Re0925c459df0493a"/>
+    <p:sldLayoutId xmlns:r="http://schemas.openxmlformats.org/officeDocument/2006/relationships" id="2147483652" r:id="R8bae402b02f44c47"/>
+    <p:sldLayoutId xmlns:r="http://schemas.openxmlformats.org/officeDocument/2006/relationships" id="2147483653" r:id="Rfb0c937aa7924351"/>
+    <p:sldLayoutId xmlns:r="http://schemas.openxmlformats.org/officeDocument/2006/relationships" id="2147483654" r:id="R69897edf04cc4127"/>
   </p:sldLayoutIdLst>
   <p:txStyles>
     <p:titleStyle>
@@ -4395,6 +4471,2963 @@
       </p:grpSpPr>
       <p:sp>
         <p:nvSpPr>
+          <p:cNvPr id="20" name="case-title">
+            <a:extLst xmlns:a="http://schemas.openxmlformats.org/drawingml/2006/main">
+              <a:ext uri="{FF2B5EF4-FFF2-40B4-BE49-F238E27FC236}">
+                <a16:creationId xmlns:a16="http://schemas.microsoft.com/office/drawing/2014/main" id="{FE819579-C189-47A0-8124-76F1D8709397}"/>
+              </a:ext>
+            </a:extLst>
+          </p:cNvPr>
+          <p:cNvSpPr>
+            <a:spLocks xmlns:a="http://schemas.openxmlformats.org/drawingml/2006/main" noGrp="1"/>
+          </p:cNvSpPr>
+          <p:nvPr/>
+        </p:nvSpPr>
+        <p:spPr>
+          <a:xfrm xmlns:a="http://schemas.openxmlformats.org/drawingml/2006/main">
+            <a:off x="685800" y="342900"/>
+            <a:ext cx="10668000" cy="590550"/>
+          </a:xfrm>
+          <a:prstGeom xmlns:a="http://schemas.openxmlformats.org/drawingml/2006/main" prst="rect">
+            <a:avLst/>
+          </a:prstGeom>
+          <a:noFill xmlns:a="http://schemas.openxmlformats.org/drawingml/2006/main"/>
+        </p:spPr>
+        <p:txBody>
+          <a:bodyPr xmlns:a="http://schemas.openxmlformats.org/drawingml/2006/main" lIns="0" tIns="0" rIns="0" bIns="0"/>
+          <a:lstStyle xmlns:a="http://schemas.openxmlformats.org/drawingml/2006/main">
+            <a:defPPr algn="l">
+              <a:defRPr sz="3450" b="1">
+                <a:solidFill>
+                  <a:srgbClr val="15334A"/>
+                </a:solidFill>
+                <a:latin typeface="Arial"/>
+                <a:ea typeface="Arial"/>
+                <a:cs typeface="Arial"/>
+              </a:defRPr>
+            </a:defPPr>
+            <a:lvl1pPr algn="l">
+              <a:defRPr sz="3450" b="1">
+                <a:solidFill>
+                  <a:srgbClr val="15334A"/>
+                </a:solidFill>
+                <a:latin typeface="Arial"/>
+                <a:ea typeface="Arial"/>
+                <a:cs typeface="Arial"/>
+              </a:defRPr>
+            </a:lvl1pPr>
+            <a:lvl2pPr algn="l">
+              <a:defRPr sz="3450" b="1">
+                <a:solidFill>
+                  <a:srgbClr val="15334A"/>
+                </a:solidFill>
+                <a:latin typeface="Arial"/>
+                <a:ea typeface="Arial"/>
+                <a:cs typeface="Arial"/>
+              </a:defRPr>
+            </a:lvl2pPr>
+            <a:lvl3pPr algn="l">
+              <a:defRPr sz="3450" b="1">
+                <a:solidFill>
+                  <a:srgbClr val="15334A"/>
+                </a:solidFill>
+                <a:latin typeface="Arial"/>
+                <a:ea typeface="Arial"/>
+                <a:cs typeface="Arial"/>
+              </a:defRPr>
+            </a:lvl3pPr>
+            <a:lvl4pPr algn="l">
+              <a:defRPr sz="3450" b="1">
+                <a:solidFill>
+                  <a:srgbClr val="15334A"/>
+                </a:solidFill>
+                <a:latin typeface="Arial"/>
+                <a:ea typeface="Arial"/>
+                <a:cs typeface="Arial"/>
+              </a:defRPr>
+            </a:lvl4pPr>
+            <a:lvl5pPr algn="l">
+              <a:defRPr sz="3450" b="1">
+                <a:solidFill>
+                  <a:srgbClr val="15334A"/>
+                </a:solidFill>
+                <a:latin typeface="Arial"/>
+                <a:ea typeface="Arial"/>
+                <a:cs typeface="Arial"/>
+              </a:defRPr>
+            </a:lvl5pPr>
+            <a:lvl6pPr algn="l">
+              <a:defRPr sz="3450" b="1">
+                <a:solidFill>
+                  <a:srgbClr val="15334A"/>
+                </a:solidFill>
+                <a:latin typeface="Arial"/>
+                <a:ea typeface="Arial"/>
+                <a:cs typeface="Arial"/>
+              </a:defRPr>
+            </a:lvl6pPr>
+            <a:lvl7pPr algn="l">
+              <a:defRPr sz="3450" b="1">
+                <a:solidFill>
+                  <a:srgbClr val="15334A"/>
+                </a:solidFill>
+                <a:latin typeface="Arial"/>
+                <a:ea typeface="Arial"/>
+                <a:cs typeface="Arial"/>
+              </a:defRPr>
+            </a:lvl7pPr>
+            <a:lvl8pPr algn="l">
+              <a:defRPr sz="3450" b="1">
+                <a:solidFill>
+                  <a:srgbClr val="15334A"/>
+                </a:solidFill>
+                <a:latin typeface="Arial"/>
+                <a:ea typeface="Arial"/>
+                <a:cs typeface="Arial"/>
+              </a:defRPr>
+            </a:lvl8pPr>
+            <a:lvl9pPr algn="l">
+              <a:defRPr sz="3450" b="1">
+                <a:solidFill>
+                  <a:srgbClr val="15334A"/>
+                </a:solidFill>
+                <a:latin typeface="Arial"/>
+                <a:ea typeface="Arial"/>
+                <a:cs typeface="Arial"/>
+              </a:defRPr>
+            </a:lvl9pPr>
+          </a:lstStyle>
+          <a:p xmlns:a="http://schemas.openxmlformats.org/drawingml/2006/main">
+            <a:pPr algn="l">
+              <a:defRPr sz="3450" b="1">
+                <a:solidFill>
+                  <a:srgbClr val="15334A"/>
+                </a:solidFill>
+                <a:latin typeface="Arial"/>
+                <a:ea typeface="Arial"/>
+                <a:cs typeface="Arial"/>
+              </a:defRPr>
+            </a:pPr>
+            <a:r>
+              <a:rPr sz="3450" b="1">
+                <a:solidFill>
+                  <a:srgbClr val="15334A"/>
+                </a:solidFill>
+                <a:latin typeface="Arial"/>
+                <a:ea typeface="Arial"/>
+                <a:cs typeface="Arial"/>
+              </a:rPr>
+              <a:t>NovaCart case overview</a:t>
+            </a:r>
+          </a:p>
+        </p:txBody>
+      </p:sp>
+      <p:sp>
+        <p:nvSpPr>
+          <p:cNvPr id="2" name="case-date">
+            <a:extLst xmlns:a="http://schemas.openxmlformats.org/drawingml/2006/main">
+              <a:ext uri="{FF2B5EF4-FFF2-40B4-BE49-F238E27FC236}">
+                <a16:creationId xmlns:a16="http://schemas.microsoft.com/office/drawing/2014/main" id="{477F31AD-5412-4CE4-8F14-92A178C4C2D1}"/>
+              </a:ext>
+            </a:extLst>
+          </p:cNvPr>
+          <p:cNvSpPr>
+            <a:spLocks xmlns:a="http://schemas.openxmlformats.org/drawingml/2006/main" noGrp="1"/>
+          </p:cNvSpPr>
+          <p:nvPr/>
+        </p:nvSpPr>
+        <p:spPr>
+          <a:xfrm xmlns:a="http://schemas.openxmlformats.org/drawingml/2006/main">
+            <a:off x="704850" y="1009650"/>
+            <a:ext cx="10477500" cy="381000"/>
+          </a:xfrm>
+          <a:prstGeom xmlns:a="http://schemas.openxmlformats.org/drawingml/2006/main" prst="rect">
+            <a:avLst/>
+          </a:prstGeom>
+          <a:noFill xmlns:a="http://schemas.openxmlformats.org/drawingml/2006/main"/>
+        </p:spPr>
+        <p:txBody>
+          <a:bodyPr xmlns:a="http://schemas.openxmlformats.org/drawingml/2006/main" lIns="0" tIns="0" rIns="0" bIns="0"/>
+          <a:lstStyle xmlns:a="http://schemas.openxmlformats.org/drawingml/2006/main">
+            <a:defPPr algn="l">
+              <a:defRPr sz="1800" b="0">
+                <a:solidFill>
+                  <a:srgbClr val="526676"/>
+                </a:solidFill>
+                <a:latin typeface="Arial"/>
+                <a:ea typeface="Arial"/>
+                <a:cs typeface="Arial"/>
+              </a:defRPr>
+            </a:defPPr>
+            <a:lvl1pPr algn="l">
+              <a:defRPr sz="1800" b="0">
+                <a:solidFill>
+                  <a:srgbClr val="526676"/>
+                </a:solidFill>
+                <a:latin typeface="Arial"/>
+                <a:ea typeface="Arial"/>
+                <a:cs typeface="Arial"/>
+              </a:defRPr>
+            </a:lvl1pPr>
+            <a:lvl2pPr algn="l">
+              <a:defRPr sz="1800" b="0">
+                <a:solidFill>
+                  <a:srgbClr val="526676"/>
+                </a:solidFill>
+                <a:latin typeface="Arial"/>
+                <a:ea typeface="Arial"/>
+                <a:cs typeface="Arial"/>
+              </a:defRPr>
+            </a:lvl2pPr>
+            <a:lvl3pPr algn="l">
+              <a:defRPr sz="1800" b="0">
+                <a:solidFill>
+                  <a:srgbClr val="526676"/>
+                </a:solidFill>
+                <a:latin typeface="Arial"/>
+                <a:ea typeface="Arial"/>
+                <a:cs typeface="Arial"/>
+              </a:defRPr>
+            </a:lvl3pPr>
+            <a:lvl4pPr algn="l">
+              <a:defRPr sz="1800" b="0">
+                <a:solidFill>
+                  <a:srgbClr val="526676"/>
+                </a:solidFill>
+                <a:latin typeface="Arial"/>
+                <a:ea typeface="Arial"/>
+                <a:cs typeface="Arial"/>
+              </a:defRPr>
+            </a:lvl4pPr>
+            <a:lvl5pPr algn="l">
+              <a:defRPr sz="1800" b="0">
+                <a:solidFill>
+                  <a:srgbClr val="526676"/>
+                </a:solidFill>
+                <a:latin typeface="Arial"/>
+                <a:ea typeface="Arial"/>
+                <a:cs typeface="Arial"/>
+              </a:defRPr>
+            </a:lvl5pPr>
+            <a:lvl6pPr algn="l">
+              <a:defRPr sz="1800" b="0">
+                <a:solidFill>
+                  <a:srgbClr val="526676"/>
+                </a:solidFill>
+                <a:latin typeface="Arial"/>
+                <a:ea typeface="Arial"/>
+                <a:cs typeface="Arial"/>
+              </a:defRPr>
+            </a:lvl6pPr>
+            <a:lvl7pPr algn="l">
+              <a:defRPr sz="1800" b="0">
+                <a:solidFill>
+                  <a:srgbClr val="526676"/>
+                </a:solidFill>
+                <a:latin typeface="Arial"/>
+                <a:ea typeface="Arial"/>
+                <a:cs typeface="Arial"/>
+              </a:defRPr>
+            </a:lvl7pPr>
+            <a:lvl8pPr algn="l">
+              <a:defRPr sz="1800" b="0">
+                <a:solidFill>
+                  <a:srgbClr val="526676"/>
+                </a:solidFill>
+                <a:latin typeface="Arial"/>
+                <a:ea typeface="Arial"/>
+                <a:cs typeface="Arial"/>
+              </a:defRPr>
+            </a:lvl8pPr>
+            <a:lvl9pPr algn="l">
+              <a:defRPr sz="1800" b="0">
+                <a:solidFill>
+                  <a:srgbClr val="526676"/>
+                </a:solidFill>
+                <a:latin typeface="Arial"/>
+                <a:ea typeface="Arial"/>
+                <a:cs typeface="Arial"/>
+              </a:defRPr>
+            </a:lvl9pPr>
+          </a:lstStyle>
+          <a:p xmlns:a="http://schemas.openxmlformats.org/drawingml/2006/main">
+            <a:pPr algn="l">
+              <a:defRPr sz="1800" b="0">
+                <a:solidFill>
+                  <a:srgbClr val="526676"/>
+                </a:solidFill>
+                <a:latin typeface="Arial"/>
+                <a:ea typeface="Arial"/>
+                <a:cs typeface="Arial"/>
+              </a:defRPr>
+            </a:pPr>
+            <a:r>
+              <a:rPr sz="1800" b="0">
+                <a:solidFill>
+                  <a:srgbClr val="526676"/>
+                </a:solidFill>
+                <a:latin typeface="Arial"/>
+                <a:ea typeface="Arial"/>
+                <a:cs typeface="Arial"/>
+              </a:rPr>
+              <a:t>Investor presentation | April 6, 2026</a:t>
+            </a:r>
+          </a:p>
+        </p:txBody>
+      </p:sp>
+      <p:sp>
+        <p:nvSpPr>
+          <p:cNvPr id="3" name="case-card-1">
+            <a:extLst xmlns:a="http://schemas.openxmlformats.org/drawingml/2006/main">
+              <a:ext uri="{FF2B5EF4-FFF2-40B4-BE49-F238E27FC236}">
+                <a16:creationId xmlns:a16="http://schemas.microsoft.com/office/drawing/2014/main" id="{F4620C99-4AEB-4175-87F9-36AB426FB6E5}"/>
+              </a:ext>
+            </a:extLst>
+          </p:cNvPr>
+          <p:cNvSpPr>
+            <a:spLocks xmlns:a="http://schemas.openxmlformats.org/drawingml/2006/main" noGrp="1"/>
+          </p:cNvSpPr>
+          <p:nvPr/>
+        </p:nvSpPr>
+        <p:spPr>
+          <a:xfrm xmlns:a="http://schemas.openxmlformats.org/drawingml/2006/main">
+            <a:off x="685800" y="1657350"/>
+            <a:ext cx="3429000" cy="2705100"/>
+          </a:xfrm>
+          <a:prstGeom xmlns:a="http://schemas.openxmlformats.org/drawingml/2006/main" prst="rect">
+            <a:avLst/>
+          </a:prstGeom>
+          <a:solidFill xmlns:a="http://schemas.openxmlformats.org/drawingml/2006/main">
+            <a:srgbClr val="F3F6F8"/>
+          </a:solidFill>
+          <a:ln xmlns:a="http://schemas.openxmlformats.org/drawingml/2006/main" w="9525">
+            <a:solidFill>
+              <a:srgbClr val="D9E2E8"/>
+            </a:solidFill>
+            <a:prstDash val="solid"/>
+          </a:ln>
+        </p:spPr>
+        <p:txBody>
+          <a:bodyPr xmlns:a="http://schemas.openxmlformats.org/drawingml/2006/main"/>
+          <a:lstStyle xmlns:a="http://schemas.openxmlformats.org/drawingml/2006/main">
+            <a:defPPr algn="l">
+              <a:defRPr sz="1650" b="0">
+                <a:solidFill>
+                  <a:srgbClr val="243746"/>
+                </a:solidFill>
+                <a:latin typeface="Arial"/>
+                <a:ea typeface="Arial"/>
+                <a:cs typeface="Arial"/>
+              </a:defRPr>
+            </a:defPPr>
+            <a:lvl1pPr algn="l">
+              <a:defRPr sz="1650" b="0">
+                <a:solidFill>
+                  <a:srgbClr val="243746"/>
+                </a:solidFill>
+                <a:latin typeface="Arial"/>
+                <a:ea typeface="Arial"/>
+                <a:cs typeface="Arial"/>
+              </a:defRPr>
+            </a:lvl1pPr>
+            <a:lvl2pPr algn="l">
+              <a:defRPr sz="1650" b="0">
+                <a:solidFill>
+                  <a:srgbClr val="243746"/>
+                </a:solidFill>
+                <a:latin typeface="Arial"/>
+                <a:ea typeface="Arial"/>
+                <a:cs typeface="Arial"/>
+              </a:defRPr>
+            </a:lvl2pPr>
+            <a:lvl3pPr algn="l">
+              <a:defRPr sz="1650" b="0">
+                <a:solidFill>
+                  <a:srgbClr val="243746"/>
+                </a:solidFill>
+                <a:latin typeface="Arial"/>
+                <a:ea typeface="Arial"/>
+                <a:cs typeface="Arial"/>
+              </a:defRPr>
+            </a:lvl3pPr>
+            <a:lvl4pPr algn="l">
+              <a:defRPr sz="1650" b="0">
+                <a:solidFill>
+                  <a:srgbClr val="243746"/>
+                </a:solidFill>
+                <a:latin typeface="Arial"/>
+                <a:ea typeface="Arial"/>
+                <a:cs typeface="Arial"/>
+              </a:defRPr>
+            </a:lvl4pPr>
+            <a:lvl5pPr algn="l">
+              <a:defRPr sz="1650" b="0">
+                <a:solidFill>
+                  <a:srgbClr val="243746"/>
+                </a:solidFill>
+                <a:latin typeface="Arial"/>
+                <a:ea typeface="Arial"/>
+                <a:cs typeface="Arial"/>
+              </a:defRPr>
+            </a:lvl5pPr>
+            <a:lvl6pPr algn="l">
+              <a:defRPr sz="1650" b="0">
+                <a:solidFill>
+                  <a:srgbClr val="243746"/>
+                </a:solidFill>
+                <a:latin typeface="Arial"/>
+                <a:ea typeface="Arial"/>
+                <a:cs typeface="Arial"/>
+              </a:defRPr>
+            </a:lvl6pPr>
+            <a:lvl7pPr algn="l">
+              <a:defRPr sz="1650" b="0">
+                <a:solidFill>
+                  <a:srgbClr val="243746"/>
+                </a:solidFill>
+                <a:latin typeface="Arial"/>
+                <a:ea typeface="Arial"/>
+                <a:cs typeface="Arial"/>
+              </a:defRPr>
+            </a:lvl7pPr>
+            <a:lvl8pPr algn="l">
+              <a:defRPr sz="1650" b="0">
+                <a:solidFill>
+                  <a:srgbClr val="243746"/>
+                </a:solidFill>
+                <a:latin typeface="Arial"/>
+                <a:ea typeface="Arial"/>
+                <a:cs typeface="Arial"/>
+              </a:defRPr>
+            </a:lvl8pPr>
+            <a:lvl9pPr algn="l">
+              <a:defRPr sz="1650" b="0">
+                <a:solidFill>
+                  <a:srgbClr val="243746"/>
+                </a:solidFill>
+                <a:latin typeface="Arial"/>
+                <a:ea typeface="Arial"/>
+                <a:cs typeface="Arial"/>
+              </a:defRPr>
+            </a:lvl9pPr>
+          </a:lstStyle>
+          <a:p xmlns:a="http://schemas.openxmlformats.org/drawingml/2006/main">
+            <a:r>
+              <a:t/>
+            </a:r>
+          </a:p>
+        </p:txBody>
+      </p:sp>
+      <p:sp>
+        <p:nvSpPr>
+          <p:cNvPr id="4" name="case-card-1-accent">
+            <a:extLst xmlns:a="http://schemas.openxmlformats.org/drawingml/2006/main">
+              <a:ext uri="{FF2B5EF4-FFF2-40B4-BE49-F238E27FC236}">
+                <a16:creationId xmlns:a16="http://schemas.microsoft.com/office/drawing/2014/main" id="{85138C85-AEF3-4C7F-A163-CD89DF75B229}"/>
+              </a:ext>
+            </a:extLst>
+          </p:cNvPr>
+          <p:cNvSpPr>
+            <a:spLocks xmlns:a="http://schemas.openxmlformats.org/drawingml/2006/main" noGrp="1"/>
+          </p:cNvSpPr>
+          <p:nvPr/>
+        </p:nvSpPr>
+        <p:spPr>
+          <a:xfrm xmlns:a="http://schemas.openxmlformats.org/drawingml/2006/main">
+            <a:off x="685800" y="1657350"/>
+            <a:ext cx="3429000" cy="76200"/>
+          </a:xfrm>
+          <a:prstGeom xmlns:a="http://schemas.openxmlformats.org/drawingml/2006/main" prst="rect">
+            <a:avLst/>
+          </a:prstGeom>
+          <a:solidFill xmlns:a="http://schemas.openxmlformats.org/drawingml/2006/main">
+            <a:srgbClr val="15334A"/>
+          </a:solidFill>
+        </p:spPr>
+        <p:txBody>
+          <a:bodyPr xmlns:a="http://schemas.openxmlformats.org/drawingml/2006/main"/>
+          <a:lstStyle xmlns:a="http://schemas.openxmlformats.org/drawingml/2006/main">
+            <a:defPPr algn="l">
+              <a:defRPr sz="1650" b="0">
+                <a:solidFill>
+                  <a:srgbClr val="243746"/>
+                </a:solidFill>
+                <a:latin typeface="Arial"/>
+                <a:ea typeface="Arial"/>
+                <a:cs typeface="Arial"/>
+              </a:defRPr>
+            </a:defPPr>
+            <a:lvl1pPr algn="l">
+              <a:defRPr sz="1650" b="0">
+                <a:solidFill>
+                  <a:srgbClr val="243746"/>
+                </a:solidFill>
+                <a:latin typeface="Arial"/>
+                <a:ea typeface="Arial"/>
+                <a:cs typeface="Arial"/>
+              </a:defRPr>
+            </a:lvl1pPr>
+            <a:lvl2pPr algn="l">
+              <a:defRPr sz="1650" b="0">
+                <a:solidFill>
+                  <a:srgbClr val="243746"/>
+                </a:solidFill>
+                <a:latin typeface="Arial"/>
+                <a:ea typeface="Arial"/>
+                <a:cs typeface="Arial"/>
+              </a:defRPr>
+            </a:lvl2pPr>
+            <a:lvl3pPr algn="l">
+              <a:defRPr sz="1650" b="0">
+                <a:solidFill>
+                  <a:srgbClr val="243746"/>
+                </a:solidFill>
+                <a:latin typeface="Arial"/>
+                <a:ea typeface="Arial"/>
+                <a:cs typeface="Arial"/>
+              </a:defRPr>
+            </a:lvl3pPr>
+            <a:lvl4pPr algn="l">
+              <a:defRPr sz="1650" b="0">
+                <a:solidFill>
+                  <a:srgbClr val="243746"/>
+                </a:solidFill>
+                <a:latin typeface="Arial"/>
+                <a:ea typeface="Arial"/>
+                <a:cs typeface="Arial"/>
+              </a:defRPr>
+            </a:lvl4pPr>
+            <a:lvl5pPr algn="l">
+              <a:defRPr sz="1650" b="0">
+                <a:solidFill>
+                  <a:srgbClr val="243746"/>
+                </a:solidFill>
+                <a:latin typeface="Arial"/>
+                <a:ea typeface="Arial"/>
+                <a:cs typeface="Arial"/>
+              </a:defRPr>
+            </a:lvl5pPr>
+            <a:lvl6pPr algn="l">
+              <a:defRPr sz="1650" b="0">
+                <a:solidFill>
+                  <a:srgbClr val="243746"/>
+                </a:solidFill>
+                <a:latin typeface="Arial"/>
+                <a:ea typeface="Arial"/>
+                <a:cs typeface="Arial"/>
+              </a:defRPr>
+            </a:lvl6pPr>
+            <a:lvl7pPr algn="l">
+              <a:defRPr sz="1650" b="0">
+                <a:solidFill>
+                  <a:srgbClr val="243746"/>
+                </a:solidFill>
+                <a:latin typeface="Arial"/>
+                <a:ea typeface="Arial"/>
+                <a:cs typeface="Arial"/>
+              </a:defRPr>
+            </a:lvl7pPr>
+            <a:lvl8pPr algn="l">
+              <a:defRPr sz="1650" b="0">
+                <a:solidFill>
+                  <a:srgbClr val="243746"/>
+                </a:solidFill>
+                <a:latin typeface="Arial"/>
+                <a:ea typeface="Arial"/>
+                <a:cs typeface="Arial"/>
+              </a:defRPr>
+            </a:lvl8pPr>
+            <a:lvl9pPr algn="l">
+              <a:defRPr sz="1650" b="0">
+                <a:solidFill>
+                  <a:srgbClr val="243746"/>
+                </a:solidFill>
+                <a:latin typeface="Arial"/>
+                <a:ea typeface="Arial"/>
+                <a:cs typeface="Arial"/>
+              </a:defRPr>
+            </a:lvl9pPr>
+          </a:lstStyle>
+          <a:p xmlns:a="http://schemas.openxmlformats.org/drawingml/2006/main">
+            <a:r>
+              <a:t/>
+            </a:r>
+          </a:p>
+        </p:txBody>
+      </p:sp>
+      <p:sp>
+        <p:nvSpPr>
+          <p:cNvPr id="5" name="case-card-1-label">
+            <a:extLst xmlns:a="http://schemas.openxmlformats.org/drawingml/2006/main">
+              <a:ext uri="{FF2B5EF4-FFF2-40B4-BE49-F238E27FC236}">
+                <a16:creationId xmlns:a16="http://schemas.microsoft.com/office/drawing/2014/main" id="{8C29F9B3-AAFF-4B4C-80FA-4E09EF8DAA01}"/>
+              </a:ext>
+            </a:extLst>
+          </p:cNvPr>
+          <p:cNvSpPr>
+            <a:spLocks xmlns:a="http://schemas.openxmlformats.org/drawingml/2006/main" noGrp="1"/>
+          </p:cNvSpPr>
+          <p:nvPr/>
+        </p:nvSpPr>
+        <p:spPr>
+          <a:xfrm xmlns:a="http://schemas.openxmlformats.org/drawingml/2006/main">
+            <a:off x="914400" y="1952625"/>
+            <a:ext cx="3009900" cy="304800"/>
+          </a:xfrm>
+          <a:prstGeom xmlns:a="http://schemas.openxmlformats.org/drawingml/2006/main" prst="rect">
+            <a:avLst/>
+          </a:prstGeom>
+          <a:noFill xmlns:a="http://schemas.openxmlformats.org/drawingml/2006/main"/>
+        </p:spPr>
+        <p:txBody>
+          <a:bodyPr xmlns:a="http://schemas.openxmlformats.org/drawingml/2006/main" lIns="0" tIns="0" rIns="0" bIns="0"/>
+          <a:lstStyle xmlns:a="http://schemas.openxmlformats.org/drawingml/2006/main">
+            <a:defPPr algn="l">
+              <a:defRPr sz="1500" b="1">
+                <a:solidFill>
+                  <a:srgbClr val="15334A"/>
+                </a:solidFill>
+                <a:latin typeface="Arial"/>
+                <a:ea typeface="Arial"/>
+                <a:cs typeface="Arial"/>
+              </a:defRPr>
+            </a:defPPr>
+            <a:lvl1pPr algn="l">
+              <a:defRPr sz="1500" b="1">
+                <a:solidFill>
+                  <a:srgbClr val="15334A"/>
+                </a:solidFill>
+                <a:latin typeface="Arial"/>
+                <a:ea typeface="Arial"/>
+                <a:cs typeface="Arial"/>
+              </a:defRPr>
+            </a:lvl1pPr>
+            <a:lvl2pPr algn="l">
+              <a:defRPr sz="1500" b="1">
+                <a:solidFill>
+                  <a:srgbClr val="15334A"/>
+                </a:solidFill>
+                <a:latin typeface="Arial"/>
+                <a:ea typeface="Arial"/>
+                <a:cs typeface="Arial"/>
+              </a:defRPr>
+            </a:lvl2pPr>
+            <a:lvl3pPr algn="l">
+              <a:defRPr sz="1500" b="1">
+                <a:solidFill>
+                  <a:srgbClr val="15334A"/>
+                </a:solidFill>
+                <a:latin typeface="Arial"/>
+                <a:ea typeface="Arial"/>
+                <a:cs typeface="Arial"/>
+              </a:defRPr>
+            </a:lvl3pPr>
+            <a:lvl4pPr algn="l">
+              <a:defRPr sz="1500" b="1">
+                <a:solidFill>
+                  <a:srgbClr val="15334A"/>
+                </a:solidFill>
+                <a:latin typeface="Arial"/>
+                <a:ea typeface="Arial"/>
+                <a:cs typeface="Arial"/>
+              </a:defRPr>
+            </a:lvl4pPr>
+            <a:lvl5pPr algn="l">
+              <a:defRPr sz="1500" b="1">
+                <a:solidFill>
+                  <a:srgbClr val="15334A"/>
+                </a:solidFill>
+                <a:latin typeface="Arial"/>
+                <a:ea typeface="Arial"/>
+                <a:cs typeface="Arial"/>
+              </a:defRPr>
+            </a:lvl5pPr>
+            <a:lvl6pPr algn="l">
+              <a:defRPr sz="1500" b="1">
+                <a:solidFill>
+                  <a:srgbClr val="15334A"/>
+                </a:solidFill>
+                <a:latin typeface="Arial"/>
+                <a:ea typeface="Arial"/>
+                <a:cs typeface="Arial"/>
+              </a:defRPr>
+            </a:lvl6pPr>
+            <a:lvl7pPr algn="l">
+              <a:defRPr sz="1500" b="1">
+                <a:solidFill>
+                  <a:srgbClr val="15334A"/>
+                </a:solidFill>
+                <a:latin typeface="Arial"/>
+                <a:ea typeface="Arial"/>
+                <a:cs typeface="Arial"/>
+              </a:defRPr>
+            </a:lvl7pPr>
+            <a:lvl8pPr algn="l">
+              <a:defRPr sz="1500" b="1">
+                <a:solidFill>
+                  <a:srgbClr val="15334A"/>
+                </a:solidFill>
+                <a:latin typeface="Arial"/>
+                <a:ea typeface="Arial"/>
+                <a:cs typeface="Arial"/>
+              </a:defRPr>
+            </a:lvl8pPr>
+            <a:lvl9pPr algn="l">
+              <a:defRPr sz="1500" b="1">
+                <a:solidFill>
+                  <a:srgbClr val="15334A"/>
+                </a:solidFill>
+                <a:latin typeface="Arial"/>
+                <a:ea typeface="Arial"/>
+                <a:cs typeface="Arial"/>
+              </a:defRPr>
+            </a:lvl9pPr>
+          </a:lstStyle>
+          <a:p xmlns:a="http://schemas.openxmlformats.org/drawingml/2006/main">
+            <a:pPr algn="l">
+              <a:defRPr sz="1500" b="1">
+                <a:solidFill>
+                  <a:srgbClr val="15334A"/>
+                </a:solidFill>
+                <a:latin typeface="Arial"/>
+                <a:ea typeface="Arial"/>
+                <a:cs typeface="Arial"/>
+              </a:defRPr>
+            </a:pPr>
+            <a:r>
+              <a:rPr sz="1500" b="1">
+                <a:solidFill>
+                  <a:srgbClr val="15334A"/>
+                </a:solidFill>
+                <a:latin typeface="Arial"/>
+                <a:ea typeface="Arial"/>
+                <a:cs typeface="Arial"/>
+              </a:rPr>
+              <a:t>THE BUSINESS</a:t>
+            </a:r>
+          </a:p>
+        </p:txBody>
+      </p:sp>
+      <p:sp>
+        <p:nvSpPr>
+          <p:cNvPr id="6" name="case-card-1-body">
+            <a:extLst xmlns:a="http://schemas.openxmlformats.org/drawingml/2006/main">
+              <a:ext uri="{FF2B5EF4-FFF2-40B4-BE49-F238E27FC236}">
+                <a16:creationId xmlns:a16="http://schemas.microsoft.com/office/drawing/2014/main" id="{F6804EDA-F889-4B75-91F1-78EEB362CD94}"/>
+              </a:ext>
+            </a:extLst>
+          </p:cNvPr>
+          <p:cNvSpPr>
+            <a:spLocks xmlns:a="http://schemas.openxmlformats.org/drawingml/2006/main" noGrp="1"/>
+          </p:cNvSpPr>
+          <p:nvPr/>
+        </p:nvSpPr>
+        <p:spPr>
+          <a:xfrm xmlns:a="http://schemas.openxmlformats.org/drawingml/2006/main">
+            <a:off x="914400" y="2400300"/>
+            <a:ext cx="2990850" cy="1714500"/>
+          </a:xfrm>
+          <a:prstGeom xmlns:a="http://schemas.openxmlformats.org/drawingml/2006/main" prst="rect">
+            <a:avLst/>
+          </a:prstGeom>
+          <a:noFill xmlns:a="http://schemas.openxmlformats.org/drawingml/2006/main"/>
+        </p:spPr>
+        <p:txBody>
+          <a:bodyPr xmlns:a="http://schemas.openxmlformats.org/drawingml/2006/main" lIns="0" tIns="0" rIns="0" bIns="0"/>
+          <a:lstStyle xmlns:a="http://schemas.openxmlformats.org/drawingml/2006/main">
+            <a:defPPr algn="l">
+              <a:defRPr sz="1800" b="0">
+                <a:solidFill>
+                  <a:srgbClr val="243746"/>
+                </a:solidFill>
+                <a:latin typeface="Arial"/>
+                <a:ea typeface="Arial"/>
+                <a:cs typeface="Arial"/>
+              </a:defRPr>
+            </a:defPPr>
+            <a:lvl1pPr algn="l">
+              <a:defRPr sz="1800" b="0">
+                <a:solidFill>
+                  <a:srgbClr val="243746"/>
+                </a:solidFill>
+                <a:latin typeface="Arial"/>
+                <a:ea typeface="Arial"/>
+                <a:cs typeface="Arial"/>
+              </a:defRPr>
+            </a:lvl1pPr>
+            <a:lvl2pPr algn="l">
+              <a:defRPr sz="1800" b="0">
+                <a:solidFill>
+                  <a:srgbClr val="243746"/>
+                </a:solidFill>
+                <a:latin typeface="Arial"/>
+                <a:ea typeface="Arial"/>
+                <a:cs typeface="Arial"/>
+              </a:defRPr>
+            </a:lvl2pPr>
+            <a:lvl3pPr algn="l">
+              <a:defRPr sz="1800" b="0">
+                <a:solidFill>
+                  <a:srgbClr val="243746"/>
+                </a:solidFill>
+                <a:latin typeface="Arial"/>
+                <a:ea typeface="Arial"/>
+                <a:cs typeface="Arial"/>
+              </a:defRPr>
+            </a:lvl3pPr>
+            <a:lvl4pPr algn="l">
+              <a:defRPr sz="1800" b="0">
+                <a:solidFill>
+                  <a:srgbClr val="243746"/>
+                </a:solidFill>
+                <a:latin typeface="Arial"/>
+                <a:ea typeface="Arial"/>
+                <a:cs typeface="Arial"/>
+              </a:defRPr>
+            </a:lvl4pPr>
+            <a:lvl5pPr algn="l">
+              <a:defRPr sz="1800" b="0">
+                <a:solidFill>
+                  <a:srgbClr val="243746"/>
+                </a:solidFill>
+                <a:latin typeface="Arial"/>
+                <a:ea typeface="Arial"/>
+                <a:cs typeface="Arial"/>
+              </a:defRPr>
+            </a:lvl5pPr>
+            <a:lvl6pPr algn="l">
+              <a:defRPr sz="1800" b="0">
+                <a:solidFill>
+                  <a:srgbClr val="243746"/>
+                </a:solidFill>
+                <a:latin typeface="Arial"/>
+                <a:ea typeface="Arial"/>
+                <a:cs typeface="Arial"/>
+              </a:defRPr>
+            </a:lvl6pPr>
+            <a:lvl7pPr algn="l">
+              <a:defRPr sz="1800" b="0">
+                <a:solidFill>
+                  <a:srgbClr val="243746"/>
+                </a:solidFill>
+                <a:latin typeface="Arial"/>
+                <a:ea typeface="Arial"/>
+                <a:cs typeface="Arial"/>
+              </a:defRPr>
+            </a:lvl7pPr>
+            <a:lvl8pPr algn="l">
+              <a:defRPr sz="1800" b="0">
+                <a:solidFill>
+                  <a:srgbClr val="243746"/>
+                </a:solidFill>
+                <a:latin typeface="Arial"/>
+                <a:ea typeface="Arial"/>
+                <a:cs typeface="Arial"/>
+              </a:defRPr>
+            </a:lvl8pPr>
+            <a:lvl9pPr algn="l">
+              <a:defRPr sz="1800" b="0">
+                <a:solidFill>
+                  <a:srgbClr val="243746"/>
+                </a:solidFill>
+                <a:latin typeface="Arial"/>
+                <a:ea typeface="Arial"/>
+                <a:cs typeface="Arial"/>
+              </a:defRPr>
+            </a:lvl9pPr>
+          </a:lstStyle>
+          <a:p xmlns:a="http://schemas.openxmlformats.org/drawingml/2006/main">
+            <a:pPr algn="l">
+              <a:defRPr sz="1800" b="0">
+                <a:solidFill>
+                  <a:srgbClr val="243746"/>
+                </a:solidFill>
+                <a:latin typeface="Arial"/>
+                <a:ea typeface="Arial"/>
+                <a:cs typeface="Arial"/>
+              </a:defRPr>
+            </a:pPr>
+            <a:r>
+              <a:rPr sz="1800" b="0">
+                <a:solidFill>
+                  <a:srgbClr val="243746"/>
+                </a:solidFill>
+                <a:latin typeface="Arial"/>
+                <a:ea typeface="Arial"/>
+                <a:cs typeface="Arial"/>
+              </a:rPr>
+              <a:t>Grocery delivery across Northeast Ohio</a:t>
+            </a:r>
+          </a:p>
+          <a:p xmlns:a="http://schemas.openxmlformats.org/drawingml/2006/main">
+            <a:pPr algn="l">
+              <a:defRPr sz="1800" b="0">
+                <a:solidFill>
+                  <a:srgbClr val="243746"/>
+                </a:solidFill>
+                <a:latin typeface="Arial"/>
+                <a:ea typeface="Arial"/>
+                <a:cs typeface="Arial"/>
+              </a:defRPr>
+            </a:pPr>
+            <a:r>
+              <a:rPr sz="1800" b="0">
+                <a:solidFill>
+                  <a:srgbClr val="243746"/>
+                </a:solidFill>
+                <a:latin typeface="Arial"/>
+                <a:ea typeface="Arial"/>
+                <a:cs typeface="Arial"/>
+              </a:rPr>
+              <a:t>Households and small business customers</a:t>
+            </a:r>
+          </a:p>
+        </p:txBody>
+      </p:sp>
+      <p:sp>
+        <p:nvSpPr>
+          <p:cNvPr id="7" name="case-card-2">
+            <a:extLst xmlns:a="http://schemas.openxmlformats.org/drawingml/2006/main">
+              <a:ext uri="{FF2B5EF4-FFF2-40B4-BE49-F238E27FC236}">
+                <a16:creationId xmlns:a16="http://schemas.microsoft.com/office/drawing/2014/main" id="{7ED76F51-149D-4737-8EE0-66E28C25627C}"/>
+              </a:ext>
+            </a:extLst>
+          </p:cNvPr>
+          <p:cNvSpPr>
+            <a:spLocks xmlns:a="http://schemas.openxmlformats.org/drawingml/2006/main" noGrp="1"/>
+          </p:cNvSpPr>
+          <p:nvPr/>
+        </p:nvSpPr>
+        <p:spPr>
+          <a:xfrm xmlns:a="http://schemas.openxmlformats.org/drawingml/2006/main">
+            <a:off x="4381500" y="1657350"/>
+            <a:ext cx="3429000" cy="2705100"/>
+          </a:xfrm>
+          <a:prstGeom xmlns:a="http://schemas.openxmlformats.org/drawingml/2006/main" prst="rect">
+            <a:avLst/>
+          </a:prstGeom>
+          <a:solidFill xmlns:a="http://schemas.openxmlformats.org/drawingml/2006/main">
+            <a:srgbClr val="F3F6F8"/>
+          </a:solidFill>
+          <a:ln xmlns:a="http://schemas.openxmlformats.org/drawingml/2006/main" w="9525">
+            <a:solidFill>
+              <a:srgbClr val="D9E2E8"/>
+            </a:solidFill>
+            <a:prstDash val="solid"/>
+          </a:ln>
+        </p:spPr>
+        <p:txBody>
+          <a:bodyPr xmlns:a="http://schemas.openxmlformats.org/drawingml/2006/main"/>
+          <a:lstStyle xmlns:a="http://schemas.openxmlformats.org/drawingml/2006/main">
+            <a:defPPr algn="l">
+              <a:defRPr sz="1650" b="0">
+                <a:solidFill>
+                  <a:srgbClr val="243746"/>
+                </a:solidFill>
+                <a:latin typeface="Arial"/>
+                <a:ea typeface="Arial"/>
+                <a:cs typeface="Arial"/>
+              </a:defRPr>
+            </a:defPPr>
+            <a:lvl1pPr algn="l">
+              <a:defRPr sz="1650" b="0">
+                <a:solidFill>
+                  <a:srgbClr val="243746"/>
+                </a:solidFill>
+                <a:latin typeface="Arial"/>
+                <a:ea typeface="Arial"/>
+                <a:cs typeface="Arial"/>
+              </a:defRPr>
+            </a:lvl1pPr>
+            <a:lvl2pPr algn="l">
+              <a:defRPr sz="1650" b="0">
+                <a:solidFill>
+                  <a:srgbClr val="243746"/>
+                </a:solidFill>
+                <a:latin typeface="Arial"/>
+                <a:ea typeface="Arial"/>
+                <a:cs typeface="Arial"/>
+              </a:defRPr>
+            </a:lvl2pPr>
+            <a:lvl3pPr algn="l">
+              <a:defRPr sz="1650" b="0">
+                <a:solidFill>
+                  <a:srgbClr val="243746"/>
+                </a:solidFill>
+                <a:latin typeface="Arial"/>
+                <a:ea typeface="Arial"/>
+                <a:cs typeface="Arial"/>
+              </a:defRPr>
+            </a:lvl3pPr>
+            <a:lvl4pPr algn="l">
+              <a:defRPr sz="1650" b="0">
+                <a:solidFill>
+                  <a:srgbClr val="243746"/>
+                </a:solidFill>
+                <a:latin typeface="Arial"/>
+                <a:ea typeface="Arial"/>
+                <a:cs typeface="Arial"/>
+              </a:defRPr>
+            </a:lvl4pPr>
+            <a:lvl5pPr algn="l">
+              <a:defRPr sz="1650" b="0">
+                <a:solidFill>
+                  <a:srgbClr val="243746"/>
+                </a:solidFill>
+                <a:latin typeface="Arial"/>
+                <a:ea typeface="Arial"/>
+                <a:cs typeface="Arial"/>
+              </a:defRPr>
+            </a:lvl5pPr>
+            <a:lvl6pPr algn="l">
+              <a:defRPr sz="1650" b="0">
+                <a:solidFill>
+                  <a:srgbClr val="243746"/>
+                </a:solidFill>
+                <a:latin typeface="Arial"/>
+                <a:ea typeface="Arial"/>
+                <a:cs typeface="Arial"/>
+              </a:defRPr>
+            </a:lvl6pPr>
+            <a:lvl7pPr algn="l">
+              <a:defRPr sz="1650" b="0">
+                <a:solidFill>
+                  <a:srgbClr val="243746"/>
+                </a:solidFill>
+                <a:latin typeface="Arial"/>
+                <a:ea typeface="Arial"/>
+                <a:cs typeface="Arial"/>
+              </a:defRPr>
+            </a:lvl7pPr>
+            <a:lvl8pPr algn="l">
+              <a:defRPr sz="1650" b="0">
+                <a:solidFill>
+                  <a:srgbClr val="243746"/>
+                </a:solidFill>
+                <a:latin typeface="Arial"/>
+                <a:ea typeface="Arial"/>
+                <a:cs typeface="Arial"/>
+              </a:defRPr>
+            </a:lvl8pPr>
+            <a:lvl9pPr algn="l">
+              <a:defRPr sz="1650" b="0">
+                <a:solidFill>
+                  <a:srgbClr val="243746"/>
+                </a:solidFill>
+                <a:latin typeface="Arial"/>
+                <a:ea typeface="Arial"/>
+                <a:cs typeface="Arial"/>
+              </a:defRPr>
+            </a:lvl9pPr>
+          </a:lstStyle>
+          <a:p xmlns:a="http://schemas.openxmlformats.org/drawingml/2006/main">
+            <a:r>
+              <a:t/>
+            </a:r>
+          </a:p>
+        </p:txBody>
+      </p:sp>
+      <p:sp>
+        <p:nvSpPr>
+          <p:cNvPr id="8" name="case-card-2-accent">
+            <a:extLst xmlns:a="http://schemas.openxmlformats.org/drawingml/2006/main">
+              <a:ext uri="{FF2B5EF4-FFF2-40B4-BE49-F238E27FC236}">
+                <a16:creationId xmlns:a16="http://schemas.microsoft.com/office/drawing/2014/main" id="{B059709C-D4F4-47AB-A639-3D0484E10387}"/>
+              </a:ext>
+            </a:extLst>
+          </p:cNvPr>
+          <p:cNvSpPr>
+            <a:spLocks xmlns:a="http://schemas.openxmlformats.org/drawingml/2006/main" noGrp="1"/>
+          </p:cNvSpPr>
+          <p:nvPr/>
+        </p:nvSpPr>
+        <p:spPr>
+          <a:xfrm xmlns:a="http://schemas.openxmlformats.org/drawingml/2006/main">
+            <a:off x="4381500" y="1657350"/>
+            <a:ext cx="3429000" cy="76200"/>
+          </a:xfrm>
+          <a:prstGeom xmlns:a="http://schemas.openxmlformats.org/drawingml/2006/main" prst="rect">
+            <a:avLst/>
+          </a:prstGeom>
+          <a:solidFill xmlns:a="http://schemas.openxmlformats.org/drawingml/2006/main">
+            <a:srgbClr val="157A72"/>
+          </a:solidFill>
+        </p:spPr>
+        <p:txBody>
+          <a:bodyPr xmlns:a="http://schemas.openxmlformats.org/drawingml/2006/main"/>
+          <a:lstStyle xmlns:a="http://schemas.openxmlformats.org/drawingml/2006/main">
+            <a:defPPr algn="l">
+              <a:defRPr sz="1650" b="0">
+                <a:solidFill>
+                  <a:srgbClr val="243746"/>
+                </a:solidFill>
+                <a:latin typeface="Arial"/>
+                <a:ea typeface="Arial"/>
+                <a:cs typeface="Arial"/>
+              </a:defRPr>
+            </a:defPPr>
+            <a:lvl1pPr algn="l">
+              <a:defRPr sz="1650" b="0">
+                <a:solidFill>
+                  <a:srgbClr val="243746"/>
+                </a:solidFill>
+                <a:latin typeface="Arial"/>
+                <a:ea typeface="Arial"/>
+                <a:cs typeface="Arial"/>
+              </a:defRPr>
+            </a:lvl1pPr>
+            <a:lvl2pPr algn="l">
+              <a:defRPr sz="1650" b="0">
+                <a:solidFill>
+                  <a:srgbClr val="243746"/>
+                </a:solidFill>
+                <a:latin typeface="Arial"/>
+                <a:ea typeface="Arial"/>
+                <a:cs typeface="Arial"/>
+              </a:defRPr>
+            </a:lvl2pPr>
+            <a:lvl3pPr algn="l">
+              <a:defRPr sz="1650" b="0">
+                <a:solidFill>
+                  <a:srgbClr val="243746"/>
+                </a:solidFill>
+                <a:latin typeface="Arial"/>
+                <a:ea typeface="Arial"/>
+                <a:cs typeface="Arial"/>
+              </a:defRPr>
+            </a:lvl3pPr>
+            <a:lvl4pPr algn="l">
+              <a:defRPr sz="1650" b="0">
+                <a:solidFill>
+                  <a:srgbClr val="243746"/>
+                </a:solidFill>
+                <a:latin typeface="Arial"/>
+                <a:ea typeface="Arial"/>
+                <a:cs typeface="Arial"/>
+              </a:defRPr>
+            </a:lvl4pPr>
+            <a:lvl5pPr algn="l">
+              <a:defRPr sz="1650" b="0">
+                <a:solidFill>
+                  <a:srgbClr val="243746"/>
+                </a:solidFill>
+                <a:latin typeface="Arial"/>
+                <a:ea typeface="Arial"/>
+                <a:cs typeface="Arial"/>
+              </a:defRPr>
+            </a:lvl5pPr>
+            <a:lvl6pPr algn="l">
+              <a:defRPr sz="1650" b="0">
+                <a:solidFill>
+                  <a:srgbClr val="243746"/>
+                </a:solidFill>
+                <a:latin typeface="Arial"/>
+                <a:ea typeface="Arial"/>
+                <a:cs typeface="Arial"/>
+              </a:defRPr>
+            </a:lvl6pPr>
+            <a:lvl7pPr algn="l">
+              <a:defRPr sz="1650" b="0">
+                <a:solidFill>
+                  <a:srgbClr val="243746"/>
+                </a:solidFill>
+                <a:latin typeface="Arial"/>
+                <a:ea typeface="Arial"/>
+                <a:cs typeface="Arial"/>
+              </a:defRPr>
+            </a:lvl7pPr>
+            <a:lvl8pPr algn="l">
+              <a:defRPr sz="1650" b="0">
+                <a:solidFill>
+                  <a:srgbClr val="243746"/>
+                </a:solidFill>
+                <a:latin typeface="Arial"/>
+                <a:ea typeface="Arial"/>
+                <a:cs typeface="Arial"/>
+              </a:defRPr>
+            </a:lvl8pPr>
+            <a:lvl9pPr algn="l">
+              <a:defRPr sz="1650" b="0">
+                <a:solidFill>
+                  <a:srgbClr val="243746"/>
+                </a:solidFill>
+                <a:latin typeface="Arial"/>
+                <a:ea typeface="Arial"/>
+                <a:cs typeface="Arial"/>
+              </a:defRPr>
+            </a:lvl9pPr>
+          </a:lstStyle>
+          <a:p xmlns:a="http://schemas.openxmlformats.org/drawingml/2006/main">
+            <a:r>
+              <a:t/>
+            </a:r>
+          </a:p>
+        </p:txBody>
+      </p:sp>
+      <p:sp>
+        <p:nvSpPr>
+          <p:cNvPr id="9" name="case-card-2-label">
+            <a:extLst xmlns:a="http://schemas.openxmlformats.org/drawingml/2006/main">
+              <a:ext uri="{FF2B5EF4-FFF2-40B4-BE49-F238E27FC236}">
+                <a16:creationId xmlns:a16="http://schemas.microsoft.com/office/drawing/2014/main" id="{E81DD679-9D88-442B-8222-CD1088C94C47}"/>
+              </a:ext>
+            </a:extLst>
+          </p:cNvPr>
+          <p:cNvSpPr>
+            <a:spLocks xmlns:a="http://schemas.openxmlformats.org/drawingml/2006/main" noGrp="1"/>
+          </p:cNvSpPr>
+          <p:nvPr/>
+        </p:nvSpPr>
+        <p:spPr>
+          <a:xfrm xmlns:a="http://schemas.openxmlformats.org/drawingml/2006/main">
+            <a:off x="4610100" y="1952625"/>
+            <a:ext cx="3009900" cy="304800"/>
+          </a:xfrm>
+          <a:prstGeom xmlns:a="http://schemas.openxmlformats.org/drawingml/2006/main" prst="rect">
+            <a:avLst/>
+          </a:prstGeom>
+          <a:noFill xmlns:a="http://schemas.openxmlformats.org/drawingml/2006/main"/>
+        </p:spPr>
+        <p:txBody>
+          <a:bodyPr xmlns:a="http://schemas.openxmlformats.org/drawingml/2006/main" lIns="0" tIns="0" rIns="0" bIns="0"/>
+          <a:lstStyle xmlns:a="http://schemas.openxmlformats.org/drawingml/2006/main">
+            <a:defPPr algn="l">
+              <a:defRPr sz="1500" b="1">
+                <a:solidFill>
+                  <a:srgbClr val="157A72"/>
+                </a:solidFill>
+                <a:latin typeface="Arial"/>
+                <a:ea typeface="Arial"/>
+                <a:cs typeface="Arial"/>
+              </a:defRPr>
+            </a:defPPr>
+            <a:lvl1pPr algn="l">
+              <a:defRPr sz="1500" b="1">
+                <a:solidFill>
+                  <a:srgbClr val="157A72"/>
+                </a:solidFill>
+                <a:latin typeface="Arial"/>
+                <a:ea typeface="Arial"/>
+                <a:cs typeface="Arial"/>
+              </a:defRPr>
+            </a:lvl1pPr>
+            <a:lvl2pPr algn="l">
+              <a:defRPr sz="1500" b="1">
+                <a:solidFill>
+                  <a:srgbClr val="157A72"/>
+                </a:solidFill>
+                <a:latin typeface="Arial"/>
+                <a:ea typeface="Arial"/>
+                <a:cs typeface="Arial"/>
+              </a:defRPr>
+            </a:lvl2pPr>
+            <a:lvl3pPr algn="l">
+              <a:defRPr sz="1500" b="1">
+                <a:solidFill>
+                  <a:srgbClr val="157A72"/>
+                </a:solidFill>
+                <a:latin typeface="Arial"/>
+                <a:ea typeface="Arial"/>
+                <a:cs typeface="Arial"/>
+              </a:defRPr>
+            </a:lvl3pPr>
+            <a:lvl4pPr algn="l">
+              <a:defRPr sz="1500" b="1">
+                <a:solidFill>
+                  <a:srgbClr val="157A72"/>
+                </a:solidFill>
+                <a:latin typeface="Arial"/>
+                <a:ea typeface="Arial"/>
+                <a:cs typeface="Arial"/>
+              </a:defRPr>
+            </a:lvl4pPr>
+            <a:lvl5pPr algn="l">
+              <a:defRPr sz="1500" b="1">
+                <a:solidFill>
+                  <a:srgbClr val="157A72"/>
+                </a:solidFill>
+                <a:latin typeface="Arial"/>
+                <a:ea typeface="Arial"/>
+                <a:cs typeface="Arial"/>
+              </a:defRPr>
+            </a:lvl5pPr>
+            <a:lvl6pPr algn="l">
+              <a:defRPr sz="1500" b="1">
+                <a:solidFill>
+                  <a:srgbClr val="157A72"/>
+                </a:solidFill>
+                <a:latin typeface="Arial"/>
+                <a:ea typeface="Arial"/>
+                <a:cs typeface="Arial"/>
+              </a:defRPr>
+            </a:lvl6pPr>
+            <a:lvl7pPr algn="l">
+              <a:defRPr sz="1500" b="1">
+                <a:solidFill>
+                  <a:srgbClr val="157A72"/>
+                </a:solidFill>
+                <a:latin typeface="Arial"/>
+                <a:ea typeface="Arial"/>
+                <a:cs typeface="Arial"/>
+              </a:defRPr>
+            </a:lvl7pPr>
+            <a:lvl8pPr algn="l">
+              <a:defRPr sz="1500" b="1">
+                <a:solidFill>
+                  <a:srgbClr val="157A72"/>
+                </a:solidFill>
+                <a:latin typeface="Arial"/>
+                <a:ea typeface="Arial"/>
+                <a:cs typeface="Arial"/>
+              </a:defRPr>
+            </a:lvl8pPr>
+            <a:lvl9pPr algn="l">
+              <a:defRPr sz="1500" b="1">
+                <a:solidFill>
+                  <a:srgbClr val="157A72"/>
+                </a:solidFill>
+                <a:latin typeface="Arial"/>
+                <a:ea typeface="Arial"/>
+                <a:cs typeface="Arial"/>
+              </a:defRPr>
+            </a:lvl9pPr>
+          </a:lstStyle>
+          <a:p xmlns:a="http://schemas.openxmlformats.org/drawingml/2006/main">
+            <a:pPr algn="l">
+              <a:defRPr sz="1500" b="1">
+                <a:solidFill>
+                  <a:srgbClr val="157A72"/>
+                </a:solidFill>
+                <a:latin typeface="Arial"/>
+                <a:ea typeface="Arial"/>
+                <a:cs typeface="Arial"/>
+              </a:defRPr>
+            </a:pPr>
+            <a:r>
+              <a:rPr sz="1500" b="1">
+                <a:solidFill>
+                  <a:srgbClr val="157A72"/>
+                </a:solidFill>
+                <a:latin typeface="Arial"/>
+                <a:ea typeface="Arial"/>
+                <a:cs typeface="Arial"/>
+              </a:rPr>
+              <a:t>THE REQUEST</a:t>
+            </a:r>
+          </a:p>
+        </p:txBody>
+      </p:sp>
+      <p:sp>
+        <p:nvSpPr>
+          <p:cNvPr id="10" name="case-card-2-body">
+            <a:extLst xmlns:a="http://schemas.openxmlformats.org/drawingml/2006/main">
+              <a:ext uri="{FF2B5EF4-FFF2-40B4-BE49-F238E27FC236}">
+                <a16:creationId xmlns:a16="http://schemas.microsoft.com/office/drawing/2014/main" id="{675B84E8-C61E-4893-8D27-F30D8C520721}"/>
+              </a:ext>
+            </a:extLst>
+          </p:cNvPr>
+          <p:cNvSpPr>
+            <a:spLocks xmlns:a="http://schemas.openxmlformats.org/drawingml/2006/main" noGrp="1"/>
+          </p:cNvSpPr>
+          <p:nvPr/>
+        </p:nvSpPr>
+        <p:spPr>
+          <a:xfrm xmlns:a="http://schemas.openxmlformats.org/drawingml/2006/main">
+            <a:off x="4610100" y="2400300"/>
+            <a:ext cx="2990850" cy="1714500"/>
+          </a:xfrm>
+          <a:prstGeom xmlns:a="http://schemas.openxmlformats.org/drawingml/2006/main" prst="rect">
+            <a:avLst/>
+          </a:prstGeom>
+          <a:noFill xmlns:a="http://schemas.openxmlformats.org/drawingml/2006/main"/>
+        </p:spPr>
+        <p:txBody>
+          <a:bodyPr xmlns:a="http://schemas.openxmlformats.org/drawingml/2006/main" lIns="0" tIns="0" rIns="0" bIns="0"/>
+          <a:lstStyle xmlns:a="http://schemas.openxmlformats.org/drawingml/2006/main">
+            <a:defPPr algn="l">
+              <a:defRPr sz="1800" b="0">
+                <a:solidFill>
+                  <a:srgbClr val="243746"/>
+                </a:solidFill>
+                <a:latin typeface="Arial"/>
+                <a:ea typeface="Arial"/>
+                <a:cs typeface="Arial"/>
+              </a:defRPr>
+            </a:defPPr>
+            <a:lvl1pPr algn="l">
+              <a:defRPr sz="1800" b="0">
+                <a:solidFill>
+                  <a:srgbClr val="243746"/>
+                </a:solidFill>
+                <a:latin typeface="Arial"/>
+                <a:ea typeface="Arial"/>
+                <a:cs typeface="Arial"/>
+              </a:defRPr>
+            </a:lvl1pPr>
+            <a:lvl2pPr algn="l">
+              <a:defRPr sz="1800" b="0">
+                <a:solidFill>
+                  <a:srgbClr val="243746"/>
+                </a:solidFill>
+                <a:latin typeface="Arial"/>
+                <a:ea typeface="Arial"/>
+                <a:cs typeface="Arial"/>
+              </a:defRPr>
+            </a:lvl2pPr>
+            <a:lvl3pPr algn="l">
+              <a:defRPr sz="1800" b="0">
+                <a:solidFill>
+                  <a:srgbClr val="243746"/>
+                </a:solidFill>
+                <a:latin typeface="Arial"/>
+                <a:ea typeface="Arial"/>
+                <a:cs typeface="Arial"/>
+              </a:defRPr>
+            </a:lvl3pPr>
+            <a:lvl4pPr algn="l">
+              <a:defRPr sz="1800" b="0">
+                <a:solidFill>
+                  <a:srgbClr val="243746"/>
+                </a:solidFill>
+                <a:latin typeface="Arial"/>
+                <a:ea typeface="Arial"/>
+                <a:cs typeface="Arial"/>
+              </a:defRPr>
+            </a:lvl4pPr>
+            <a:lvl5pPr algn="l">
+              <a:defRPr sz="1800" b="0">
+                <a:solidFill>
+                  <a:srgbClr val="243746"/>
+                </a:solidFill>
+                <a:latin typeface="Arial"/>
+                <a:ea typeface="Arial"/>
+                <a:cs typeface="Arial"/>
+              </a:defRPr>
+            </a:lvl5pPr>
+            <a:lvl6pPr algn="l">
+              <a:defRPr sz="1800" b="0">
+                <a:solidFill>
+                  <a:srgbClr val="243746"/>
+                </a:solidFill>
+                <a:latin typeface="Arial"/>
+                <a:ea typeface="Arial"/>
+                <a:cs typeface="Arial"/>
+              </a:defRPr>
+            </a:lvl6pPr>
+            <a:lvl7pPr algn="l">
+              <a:defRPr sz="1800" b="0">
+                <a:solidFill>
+                  <a:srgbClr val="243746"/>
+                </a:solidFill>
+                <a:latin typeface="Arial"/>
+                <a:ea typeface="Arial"/>
+                <a:cs typeface="Arial"/>
+              </a:defRPr>
+            </a:lvl7pPr>
+            <a:lvl8pPr algn="l">
+              <a:defRPr sz="1800" b="0">
+                <a:solidFill>
+                  <a:srgbClr val="243746"/>
+                </a:solidFill>
+                <a:latin typeface="Arial"/>
+                <a:ea typeface="Arial"/>
+                <a:cs typeface="Arial"/>
+              </a:defRPr>
+            </a:lvl8pPr>
+            <a:lvl9pPr algn="l">
+              <a:defRPr sz="1800" b="0">
+                <a:solidFill>
+                  <a:srgbClr val="243746"/>
+                </a:solidFill>
+                <a:latin typeface="Arial"/>
+                <a:ea typeface="Arial"/>
+                <a:cs typeface="Arial"/>
+              </a:defRPr>
+            </a:lvl9pPr>
+          </a:lstStyle>
+          <a:p xmlns:a="http://schemas.openxmlformats.org/drawingml/2006/main">
+            <a:pPr algn="l">
+              <a:defRPr sz="1800" b="0">
+                <a:solidFill>
+                  <a:srgbClr val="243746"/>
+                </a:solidFill>
+                <a:latin typeface="Arial"/>
+                <a:ea typeface="Arial"/>
+                <a:cs typeface="Arial"/>
+              </a:defRPr>
+            </a:pPr>
+            <a:r>
+              <a:rPr sz="1800" b="0">
+                <a:solidFill>
+                  <a:srgbClr val="243746"/>
+                </a:solidFill>
+                <a:latin typeface="Arial"/>
+                <a:ea typeface="Arial"/>
+                <a:cs typeface="Arial"/>
+              </a:rPr>
+              <a:t>$500,000</a:t>
+            </a:r>
+          </a:p>
+          <a:p xmlns:a="http://schemas.openxmlformats.org/drawingml/2006/main">
+            <a:pPr algn="l">
+              <a:defRPr sz="1800" b="0">
+                <a:solidFill>
+                  <a:srgbClr val="243746"/>
+                </a:solidFill>
+                <a:latin typeface="Arial"/>
+                <a:ea typeface="Arial"/>
+                <a:cs typeface="Arial"/>
+              </a:defRPr>
+            </a:pPr>
+            <a:r>
+              <a:rPr sz="1800" b="0">
+                <a:solidFill>
+                  <a:srgbClr val="243746"/>
+                </a:solidFill>
+                <a:latin typeface="Arial"/>
+                <a:ea typeface="Arial"/>
+                <a:cs typeface="Arial"/>
+              </a:rPr>
+              <a:t>Expand delivery coverage and acquire customers over the next 12 months</a:t>
+            </a:r>
+          </a:p>
+        </p:txBody>
+      </p:sp>
+      <p:sp>
+        <p:nvSpPr>
+          <p:cNvPr id="11" name="case-card-3">
+            <a:extLst xmlns:a="http://schemas.openxmlformats.org/drawingml/2006/main">
+              <a:ext uri="{FF2B5EF4-FFF2-40B4-BE49-F238E27FC236}">
+                <a16:creationId xmlns:a16="http://schemas.microsoft.com/office/drawing/2014/main" id="{12E7DC0B-1DF8-4F44-88E5-B398D1CE7331}"/>
+              </a:ext>
+            </a:extLst>
+          </p:cNvPr>
+          <p:cNvSpPr>
+            <a:spLocks xmlns:a="http://schemas.openxmlformats.org/drawingml/2006/main" noGrp="1"/>
+          </p:cNvSpPr>
+          <p:nvPr/>
+        </p:nvSpPr>
+        <p:spPr>
+          <a:xfrm xmlns:a="http://schemas.openxmlformats.org/drawingml/2006/main">
+            <a:off x="8077200" y="1657350"/>
+            <a:ext cx="3429000" cy="2705100"/>
+          </a:xfrm>
+          <a:prstGeom xmlns:a="http://schemas.openxmlformats.org/drawingml/2006/main" prst="rect">
+            <a:avLst/>
+          </a:prstGeom>
+          <a:solidFill xmlns:a="http://schemas.openxmlformats.org/drawingml/2006/main">
+            <a:srgbClr val="F3F6F8"/>
+          </a:solidFill>
+          <a:ln xmlns:a="http://schemas.openxmlformats.org/drawingml/2006/main" w="9525">
+            <a:solidFill>
+              <a:srgbClr val="D9E2E8"/>
+            </a:solidFill>
+            <a:prstDash val="solid"/>
+          </a:ln>
+        </p:spPr>
+        <p:txBody>
+          <a:bodyPr xmlns:a="http://schemas.openxmlformats.org/drawingml/2006/main"/>
+          <a:lstStyle xmlns:a="http://schemas.openxmlformats.org/drawingml/2006/main">
+            <a:defPPr algn="l">
+              <a:defRPr sz="1650" b="0">
+                <a:solidFill>
+                  <a:srgbClr val="243746"/>
+                </a:solidFill>
+                <a:latin typeface="Arial"/>
+                <a:ea typeface="Arial"/>
+                <a:cs typeface="Arial"/>
+              </a:defRPr>
+            </a:defPPr>
+            <a:lvl1pPr algn="l">
+              <a:defRPr sz="1650" b="0">
+                <a:solidFill>
+                  <a:srgbClr val="243746"/>
+                </a:solidFill>
+                <a:latin typeface="Arial"/>
+                <a:ea typeface="Arial"/>
+                <a:cs typeface="Arial"/>
+              </a:defRPr>
+            </a:lvl1pPr>
+            <a:lvl2pPr algn="l">
+              <a:defRPr sz="1650" b="0">
+                <a:solidFill>
+                  <a:srgbClr val="243746"/>
+                </a:solidFill>
+                <a:latin typeface="Arial"/>
+                <a:ea typeface="Arial"/>
+                <a:cs typeface="Arial"/>
+              </a:defRPr>
+            </a:lvl2pPr>
+            <a:lvl3pPr algn="l">
+              <a:defRPr sz="1650" b="0">
+                <a:solidFill>
+                  <a:srgbClr val="243746"/>
+                </a:solidFill>
+                <a:latin typeface="Arial"/>
+                <a:ea typeface="Arial"/>
+                <a:cs typeface="Arial"/>
+              </a:defRPr>
+            </a:lvl3pPr>
+            <a:lvl4pPr algn="l">
+              <a:defRPr sz="1650" b="0">
+                <a:solidFill>
+                  <a:srgbClr val="243746"/>
+                </a:solidFill>
+                <a:latin typeface="Arial"/>
+                <a:ea typeface="Arial"/>
+                <a:cs typeface="Arial"/>
+              </a:defRPr>
+            </a:lvl4pPr>
+            <a:lvl5pPr algn="l">
+              <a:defRPr sz="1650" b="0">
+                <a:solidFill>
+                  <a:srgbClr val="243746"/>
+                </a:solidFill>
+                <a:latin typeface="Arial"/>
+                <a:ea typeface="Arial"/>
+                <a:cs typeface="Arial"/>
+              </a:defRPr>
+            </a:lvl5pPr>
+            <a:lvl6pPr algn="l">
+              <a:defRPr sz="1650" b="0">
+                <a:solidFill>
+                  <a:srgbClr val="243746"/>
+                </a:solidFill>
+                <a:latin typeface="Arial"/>
+                <a:ea typeface="Arial"/>
+                <a:cs typeface="Arial"/>
+              </a:defRPr>
+            </a:lvl6pPr>
+            <a:lvl7pPr algn="l">
+              <a:defRPr sz="1650" b="0">
+                <a:solidFill>
+                  <a:srgbClr val="243746"/>
+                </a:solidFill>
+                <a:latin typeface="Arial"/>
+                <a:ea typeface="Arial"/>
+                <a:cs typeface="Arial"/>
+              </a:defRPr>
+            </a:lvl7pPr>
+            <a:lvl8pPr algn="l">
+              <a:defRPr sz="1650" b="0">
+                <a:solidFill>
+                  <a:srgbClr val="243746"/>
+                </a:solidFill>
+                <a:latin typeface="Arial"/>
+                <a:ea typeface="Arial"/>
+                <a:cs typeface="Arial"/>
+              </a:defRPr>
+            </a:lvl8pPr>
+            <a:lvl9pPr algn="l">
+              <a:defRPr sz="1650" b="0">
+                <a:solidFill>
+                  <a:srgbClr val="243746"/>
+                </a:solidFill>
+                <a:latin typeface="Arial"/>
+                <a:ea typeface="Arial"/>
+                <a:cs typeface="Arial"/>
+              </a:defRPr>
+            </a:lvl9pPr>
+          </a:lstStyle>
+          <a:p xmlns:a="http://schemas.openxmlformats.org/drawingml/2006/main">
+            <a:r>
+              <a:t/>
+            </a:r>
+          </a:p>
+        </p:txBody>
+      </p:sp>
+      <p:sp>
+        <p:nvSpPr>
+          <p:cNvPr id="12" name="case-card-3-accent">
+            <a:extLst xmlns:a="http://schemas.openxmlformats.org/drawingml/2006/main">
+              <a:ext uri="{FF2B5EF4-FFF2-40B4-BE49-F238E27FC236}">
+                <a16:creationId xmlns:a16="http://schemas.microsoft.com/office/drawing/2014/main" id="{8D2EB449-D6EE-42C9-8F61-A1C648E897B3}"/>
+              </a:ext>
+            </a:extLst>
+          </p:cNvPr>
+          <p:cNvSpPr>
+            <a:spLocks xmlns:a="http://schemas.openxmlformats.org/drawingml/2006/main" noGrp="1"/>
+          </p:cNvSpPr>
+          <p:nvPr/>
+        </p:nvSpPr>
+        <p:spPr>
+          <a:xfrm xmlns:a="http://schemas.openxmlformats.org/drawingml/2006/main">
+            <a:off x="8077200" y="1657350"/>
+            <a:ext cx="3429000" cy="76200"/>
+          </a:xfrm>
+          <a:prstGeom xmlns:a="http://schemas.openxmlformats.org/drawingml/2006/main" prst="rect">
+            <a:avLst/>
+          </a:prstGeom>
+          <a:solidFill xmlns:a="http://schemas.openxmlformats.org/drawingml/2006/main">
+            <a:srgbClr val="B7533E"/>
+          </a:solidFill>
+        </p:spPr>
+        <p:txBody>
+          <a:bodyPr xmlns:a="http://schemas.openxmlformats.org/drawingml/2006/main"/>
+          <a:lstStyle xmlns:a="http://schemas.openxmlformats.org/drawingml/2006/main">
+            <a:defPPr algn="l">
+              <a:defRPr sz="1650" b="0">
+                <a:solidFill>
+                  <a:srgbClr val="243746"/>
+                </a:solidFill>
+                <a:latin typeface="Arial"/>
+                <a:ea typeface="Arial"/>
+                <a:cs typeface="Arial"/>
+              </a:defRPr>
+            </a:defPPr>
+            <a:lvl1pPr algn="l">
+              <a:defRPr sz="1650" b="0">
+                <a:solidFill>
+                  <a:srgbClr val="243746"/>
+                </a:solidFill>
+                <a:latin typeface="Arial"/>
+                <a:ea typeface="Arial"/>
+                <a:cs typeface="Arial"/>
+              </a:defRPr>
+            </a:lvl1pPr>
+            <a:lvl2pPr algn="l">
+              <a:defRPr sz="1650" b="0">
+                <a:solidFill>
+                  <a:srgbClr val="243746"/>
+                </a:solidFill>
+                <a:latin typeface="Arial"/>
+                <a:ea typeface="Arial"/>
+                <a:cs typeface="Arial"/>
+              </a:defRPr>
+            </a:lvl2pPr>
+            <a:lvl3pPr algn="l">
+              <a:defRPr sz="1650" b="0">
+                <a:solidFill>
+                  <a:srgbClr val="243746"/>
+                </a:solidFill>
+                <a:latin typeface="Arial"/>
+                <a:ea typeface="Arial"/>
+                <a:cs typeface="Arial"/>
+              </a:defRPr>
+            </a:lvl3pPr>
+            <a:lvl4pPr algn="l">
+              <a:defRPr sz="1650" b="0">
+                <a:solidFill>
+                  <a:srgbClr val="243746"/>
+                </a:solidFill>
+                <a:latin typeface="Arial"/>
+                <a:ea typeface="Arial"/>
+                <a:cs typeface="Arial"/>
+              </a:defRPr>
+            </a:lvl4pPr>
+            <a:lvl5pPr algn="l">
+              <a:defRPr sz="1650" b="0">
+                <a:solidFill>
+                  <a:srgbClr val="243746"/>
+                </a:solidFill>
+                <a:latin typeface="Arial"/>
+                <a:ea typeface="Arial"/>
+                <a:cs typeface="Arial"/>
+              </a:defRPr>
+            </a:lvl5pPr>
+            <a:lvl6pPr algn="l">
+              <a:defRPr sz="1650" b="0">
+                <a:solidFill>
+                  <a:srgbClr val="243746"/>
+                </a:solidFill>
+                <a:latin typeface="Arial"/>
+                <a:ea typeface="Arial"/>
+                <a:cs typeface="Arial"/>
+              </a:defRPr>
+            </a:lvl6pPr>
+            <a:lvl7pPr algn="l">
+              <a:defRPr sz="1650" b="0">
+                <a:solidFill>
+                  <a:srgbClr val="243746"/>
+                </a:solidFill>
+                <a:latin typeface="Arial"/>
+                <a:ea typeface="Arial"/>
+                <a:cs typeface="Arial"/>
+              </a:defRPr>
+            </a:lvl7pPr>
+            <a:lvl8pPr algn="l">
+              <a:defRPr sz="1650" b="0">
+                <a:solidFill>
+                  <a:srgbClr val="243746"/>
+                </a:solidFill>
+                <a:latin typeface="Arial"/>
+                <a:ea typeface="Arial"/>
+                <a:cs typeface="Arial"/>
+              </a:defRPr>
+            </a:lvl8pPr>
+            <a:lvl9pPr algn="l">
+              <a:defRPr sz="1650" b="0">
+                <a:solidFill>
+                  <a:srgbClr val="243746"/>
+                </a:solidFill>
+                <a:latin typeface="Arial"/>
+                <a:ea typeface="Arial"/>
+                <a:cs typeface="Arial"/>
+              </a:defRPr>
+            </a:lvl9pPr>
+          </a:lstStyle>
+          <a:p xmlns:a="http://schemas.openxmlformats.org/drawingml/2006/main">
+            <a:r>
+              <a:t/>
+            </a:r>
+          </a:p>
+        </p:txBody>
+      </p:sp>
+      <p:sp>
+        <p:nvSpPr>
+          <p:cNvPr id="13" name="case-card-3-label">
+            <a:extLst xmlns:a="http://schemas.openxmlformats.org/drawingml/2006/main">
+              <a:ext uri="{FF2B5EF4-FFF2-40B4-BE49-F238E27FC236}">
+                <a16:creationId xmlns:a16="http://schemas.microsoft.com/office/drawing/2014/main" id="{7D06AF4A-AEB3-4336-BD9D-FA9CF49946F0}"/>
+              </a:ext>
+            </a:extLst>
+          </p:cNvPr>
+          <p:cNvSpPr>
+            <a:spLocks xmlns:a="http://schemas.openxmlformats.org/drawingml/2006/main" noGrp="1"/>
+          </p:cNvSpPr>
+          <p:nvPr/>
+        </p:nvSpPr>
+        <p:spPr>
+          <a:xfrm xmlns:a="http://schemas.openxmlformats.org/drawingml/2006/main">
+            <a:off x="8305800" y="1952625"/>
+            <a:ext cx="3009900" cy="304800"/>
+          </a:xfrm>
+          <a:prstGeom xmlns:a="http://schemas.openxmlformats.org/drawingml/2006/main" prst="rect">
+            <a:avLst/>
+          </a:prstGeom>
+          <a:noFill xmlns:a="http://schemas.openxmlformats.org/drawingml/2006/main"/>
+        </p:spPr>
+        <p:txBody>
+          <a:bodyPr xmlns:a="http://schemas.openxmlformats.org/drawingml/2006/main" lIns="0" tIns="0" rIns="0" bIns="0"/>
+          <a:lstStyle xmlns:a="http://schemas.openxmlformats.org/drawingml/2006/main">
+            <a:defPPr algn="l">
+              <a:defRPr sz="1500" b="1">
+                <a:solidFill>
+                  <a:srgbClr val="B7533E"/>
+                </a:solidFill>
+                <a:latin typeface="Arial"/>
+                <a:ea typeface="Arial"/>
+                <a:cs typeface="Arial"/>
+              </a:defRPr>
+            </a:defPPr>
+            <a:lvl1pPr algn="l">
+              <a:defRPr sz="1500" b="1">
+                <a:solidFill>
+                  <a:srgbClr val="B7533E"/>
+                </a:solidFill>
+                <a:latin typeface="Arial"/>
+                <a:ea typeface="Arial"/>
+                <a:cs typeface="Arial"/>
+              </a:defRPr>
+            </a:lvl1pPr>
+            <a:lvl2pPr algn="l">
+              <a:defRPr sz="1500" b="1">
+                <a:solidFill>
+                  <a:srgbClr val="B7533E"/>
+                </a:solidFill>
+                <a:latin typeface="Arial"/>
+                <a:ea typeface="Arial"/>
+                <a:cs typeface="Arial"/>
+              </a:defRPr>
+            </a:lvl2pPr>
+            <a:lvl3pPr algn="l">
+              <a:defRPr sz="1500" b="1">
+                <a:solidFill>
+                  <a:srgbClr val="B7533E"/>
+                </a:solidFill>
+                <a:latin typeface="Arial"/>
+                <a:ea typeface="Arial"/>
+                <a:cs typeface="Arial"/>
+              </a:defRPr>
+            </a:lvl3pPr>
+            <a:lvl4pPr algn="l">
+              <a:defRPr sz="1500" b="1">
+                <a:solidFill>
+                  <a:srgbClr val="B7533E"/>
+                </a:solidFill>
+                <a:latin typeface="Arial"/>
+                <a:ea typeface="Arial"/>
+                <a:cs typeface="Arial"/>
+              </a:defRPr>
+            </a:lvl4pPr>
+            <a:lvl5pPr algn="l">
+              <a:defRPr sz="1500" b="1">
+                <a:solidFill>
+                  <a:srgbClr val="B7533E"/>
+                </a:solidFill>
+                <a:latin typeface="Arial"/>
+                <a:ea typeface="Arial"/>
+                <a:cs typeface="Arial"/>
+              </a:defRPr>
+            </a:lvl5pPr>
+            <a:lvl6pPr algn="l">
+              <a:defRPr sz="1500" b="1">
+                <a:solidFill>
+                  <a:srgbClr val="B7533E"/>
+                </a:solidFill>
+                <a:latin typeface="Arial"/>
+                <a:ea typeface="Arial"/>
+                <a:cs typeface="Arial"/>
+              </a:defRPr>
+            </a:lvl6pPr>
+            <a:lvl7pPr algn="l">
+              <a:defRPr sz="1500" b="1">
+                <a:solidFill>
+                  <a:srgbClr val="B7533E"/>
+                </a:solidFill>
+                <a:latin typeface="Arial"/>
+                <a:ea typeface="Arial"/>
+                <a:cs typeface="Arial"/>
+              </a:defRPr>
+            </a:lvl7pPr>
+            <a:lvl8pPr algn="l">
+              <a:defRPr sz="1500" b="1">
+                <a:solidFill>
+                  <a:srgbClr val="B7533E"/>
+                </a:solidFill>
+                <a:latin typeface="Arial"/>
+                <a:ea typeface="Arial"/>
+                <a:cs typeface="Arial"/>
+              </a:defRPr>
+            </a:lvl8pPr>
+            <a:lvl9pPr algn="l">
+              <a:defRPr sz="1500" b="1">
+                <a:solidFill>
+                  <a:srgbClr val="B7533E"/>
+                </a:solidFill>
+                <a:latin typeface="Arial"/>
+                <a:ea typeface="Arial"/>
+                <a:cs typeface="Arial"/>
+              </a:defRPr>
+            </a:lvl9pPr>
+          </a:lstStyle>
+          <a:p xmlns:a="http://schemas.openxmlformats.org/drawingml/2006/main">
+            <a:pPr algn="l">
+              <a:defRPr sz="1500" b="1">
+                <a:solidFill>
+                  <a:srgbClr val="B7533E"/>
+                </a:solidFill>
+                <a:latin typeface="Arial"/>
+                <a:ea typeface="Arial"/>
+                <a:cs typeface="Arial"/>
+              </a:defRPr>
+            </a:pPr>
+            <a:r>
+              <a:rPr sz="1500" b="1">
+                <a:solidFill>
+                  <a:srgbClr val="B7533E"/>
+                </a:solidFill>
+                <a:latin typeface="Arial"/>
+                <a:ea typeface="Arial"/>
+                <a:cs typeface="Arial"/>
+              </a:rPr>
+              <a:t>MANAGEMENT’S CLAIMS</a:t>
+            </a:r>
+          </a:p>
+        </p:txBody>
+      </p:sp>
+      <p:sp>
+        <p:nvSpPr>
+          <p:cNvPr id="14" name="case-card-3-body">
+            <a:extLst xmlns:a="http://schemas.openxmlformats.org/drawingml/2006/main">
+              <a:ext uri="{FF2B5EF4-FFF2-40B4-BE49-F238E27FC236}">
+                <a16:creationId xmlns:a16="http://schemas.microsoft.com/office/drawing/2014/main" id="{C5610483-7F23-463F-8902-DE1627CF0F6F}"/>
+              </a:ext>
+            </a:extLst>
+          </p:cNvPr>
+          <p:cNvSpPr>
+            <a:spLocks xmlns:a="http://schemas.openxmlformats.org/drawingml/2006/main" noGrp="1"/>
+          </p:cNvSpPr>
+          <p:nvPr/>
+        </p:nvSpPr>
+        <p:spPr>
+          <a:xfrm xmlns:a="http://schemas.openxmlformats.org/drawingml/2006/main">
+            <a:off x="8305800" y="2400300"/>
+            <a:ext cx="2990850" cy="1714500"/>
+          </a:xfrm>
+          <a:prstGeom xmlns:a="http://schemas.openxmlformats.org/drawingml/2006/main" prst="rect">
+            <a:avLst/>
+          </a:prstGeom>
+          <a:noFill xmlns:a="http://schemas.openxmlformats.org/drawingml/2006/main"/>
+        </p:spPr>
+        <p:txBody>
+          <a:bodyPr xmlns:a="http://schemas.openxmlformats.org/drawingml/2006/main" lIns="0" tIns="0" rIns="0" bIns="0"/>
+          <a:lstStyle xmlns:a="http://schemas.openxmlformats.org/drawingml/2006/main">
+            <a:defPPr algn="l">
+              <a:defRPr sz="1575" b="0">
+                <a:solidFill>
+                  <a:srgbClr val="243746"/>
+                </a:solidFill>
+                <a:latin typeface="Arial"/>
+                <a:ea typeface="Arial"/>
+                <a:cs typeface="Arial"/>
+              </a:defRPr>
+            </a:defPPr>
+            <a:lvl1pPr algn="l">
+              <a:defRPr sz="1575" b="0">
+                <a:solidFill>
+                  <a:srgbClr val="243746"/>
+                </a:solidFill>
+                <a:latin typeface="Arial"/>
+                <a:ea typeface="Arial"/>
+                <a:cs typeface="Arial"/>
+              </a:defRPr>
+            </a:lvl1pPr>
+            <a:lvl2pPr algn="l">
+              <a:defRPr sz="1575" b="0">
+                <a:solidFill>
+                  <a:srgbClr val="243746"/>
+                </a:solidFill>
+                <a:latin typeface="Arial"/>
+                <a:ea typeface="Arial"/>
+                <a:cs typeface="Arial"/>
+              </a:defRPr>
+            </a:lvl2pPr>
+            <a:lvl3pPr algn="l">
+              <a:defRPr sz="1575" b="0">
+                <a:solidFill>
+                  <a:srgbClr val="243746"/>
+                </a:solidFill>
+                <a:latin typeface="Arial"/>
+                <a:ea typeface="Arial"/>
+                <a:cs typeface="Arial"/>
+              </a:defRPr>
+            </a:lvl3pPr>
+            <a:lvl4pPr algn="l">
+              <a:defRPr sz="1575" b="0">
+                <a:solidFill>
+                  <a:srgbClr val="243746"/>
+                </a:solidFill>
+                <a:latin typeface="Arial"/>
+                <a:ea typeface="Arial"/>
+                <a:cs typeface="Arial"/>
+              </a:defRPr>
+            </a:lvl4pPr>
+            <a:lvl5pPr algn="l">
+              <a:defRPr sz="1575" b="0">
+                <a:solidFill>
+                  <a:srgbClr val="243746"/>
+                </a:solidFill>
+                <a:latin typeface="Arial"/>
+                <a:ea typeface="Arial"/>
+                <a:cs typeface="Arial"/>
+              </a:defRPr>
+            </a:lvl5pPr>
+            <a:lvl6pPr algn="l">
+              <a:defRPr sz="1575" b="0">
+                <a:solidFill>
+                  <a:srgbClr val="243746"/>
+                </a:solidFill>
+                <a:latin typeface="Arial"/>
+                <a:ea typeface="Arial"/>
+                <a:cs typeface="Arial"/>
+              </a:defRPr>
+            </a:lvl6pPr>
+            <a:lvl7pPr algn="l">
+              <a:defRPr sz="1575" b="0">
+                <a:solidFill>
+                  <a:srgbClr val="243746"/>
+                </a:solidFill>
+                <a:latin typeface="Arial"/>
+                <a:ea typeface="Arial"/>
+                <a:cs typeface="Arial"/>
+              </a:defRPr>
+            </a:lvl7pPr>
+            <a:lvl8pPr algn="l">
+              <a:defRPr sz="1575" b="0">
+                <a:solidFill>
+                  <a:srgbClr val="243746"/>
+                </a:solidFill>
+                <a:latin typeface="Arial"/>
+                <a:ea typeface="Arial"/>
+                <a:cs typeface="Arial"/>
+              </a:defRPr>
+            </a:lvl8pPr>
+            <a:lvl9pPr algn="l">
+              <a:defRPr sz="1575" b="0">
+                <a:solidFill>
+                  <a:srgbClr val="243746"/>
+                </a:solidFill>
+                <a:latin typeface="Arial"/>
+                <a:ea typeface="Arial"/>
+                <a:cs typeface="Arial"/>
+              </a:defRPr>
+            </a:lvl9pPr>
+          </a:lstStyle>
+          <a:p xmlns:a="http://schemas.openxmlformats.org/drawingml/2006/main">
+            <a:pPr algn="l">
+              <a:defRPr sz="1575" b="0">
+                <a:solidFill>
+                  <a:srgbClr val="243746"/>
+                </a:solidFill>
+                <a:latin typeface="Arial"/>
+                <a:ea typeface="Arial"/>
+                <a:cs typeface="Arial"/>
+              </a:defRPr>
+            </a:pPr>
+            <a:r>
+              <a:rPr sz="1575" b="0">
+                <a:solidFill>
+                  <a:srgbClr val="243746"/>
+                </a:solidFill>
+                <a:latin typeface="Arial"/>
+                <a:ea typeface="Arial"/>
+                <a:cs typeface="Arial"/>
+              </a:rPr>
+              <a:t>2024 revenue: $300,000</a:t>
+            </a:r>
+          </a:p>
+          <a:p xmlns:a="http://schemas.openxmlformats.org/drawingml/2006/main">
+            <a:pPr algn="l">
+              <a:defRPr sz="1575" b="0">
+                <a:solidFill>
+                  <a:srgbClr val="243746"/>
+                </a:solidFill>
+                <a:latin typeface="Arial"/>
+                <a:ea typeface="Arial"/>
+                <a:cs typeface="Arial"/>
+              </a:defRPr>
+            </a:pPr>
+            <a:r>
+              <a:rPr sz="1575" b="0">
+                <a:solidFill>
+                  <a:srgbClr val="243746"/>
+                </a:solidFill>
+                <a:latin typeface="Arial"/>
+                <a:ea typeface="Arial"/>
+                <a:cs typeface="Arial"/>
+              </a:rPr>
+              <a:t>2025 revenue: $1,200,000 (300% growth)</a:t>
+            </a:r>
+          </a:p>
+          <a:p xmlns:a="http://schemas.openxmlformats.org/drawingml/2006/main">
+            <a:pPr algn="l">
+              <a:defRPr sz="1575" b="0">
+                <a:solidFill>
+                  <a:srgbClr val="243746"/>
+                </a:solidFill>
+                <a:latin typeface="Arial"/>
+                <a:ea typeface="Arial"/>
+                <a:cs typeface="Arial"/>
+              </a:defRPr>
+            </a:pPr>
+            <a:r>
+              <a:rPr sz="1575" b="0">
+                <a:solidFill>
+                  <a:srgbClr val="243746"/>
+                </a:solidFill>
+                <a:latin typeface="Arial"/>
+                <a:ea typeface="Arial"/>
+                <a:cs typeface="Arial"/>
+              </a:rPr>
+              <a:t>4,000 active customers</a:t>
+            </a:r>
+          </a:p>
+          <a:p xmlns:a="http://schemas.openxmlformats.org/drawingml/2006/main">
+            <a:pPr algn="l">
+              <a:defRPr sz="1575" b="0">
+                <a:solidFill>
+                  <a:srgbClr val="243746"/>
+                </a:solidFill>
+                <a:latin typeface="Arial"/>
+                <a:ea typeface="Arial"/>
+                <a:cs typeface="Arial"/>
+              </a:defRPr>
+            </a:pPr>
+            <a:r>
+              <a:rPr sz="1575" b="0">
+                <a:solidFill>
+                  <a:srgbClr val="243746"/>
+                </a:solidFill>
+                <a:latin typeface="Arial"/>
+                <a:ea typeface="Arial"/>
+                <a:cs typeface="Arial"/>
+              </a:rPr>
+              <a:t>Profitable since Q3 2025</a:t>
+            </a:r>
+          </a:p>
+        </p:txBody>
+      </p:sp>
+      <p:sp>
+        <p:nvSpPr>
+          <p:cNvPr id="15" name="investment-question-band">
+            <a:extLst xmlns:a="http://schemas.openxmlformats.org/drawingml/2006/main">
+              <a:ext uri="{FF2B5EF4-FFF2-40B4-BE49-F238E27FC236}">
+                <a16:creationId xmlns:a16="http://schemas.microsoft.com/office/drawing/2014/main" id="{94FC4D5B-93DA-46AC-B8B6-116DEC8BC5BE}"/>
+              </a:ext>
+            </a:extLst>
+          </p:cNvPr>
+          <p:cNvSpPr>
+            <a:spLocks xmlns:a="http://schemas.openxmlformats.org/drawingml/2006/main" noGrp="1"/>
+          </p:cNvSpPr>
+          <p:nvPr/>
+        </p:nvSpPr>
+        <p:spPr>
+          <a:xfrm xmlns:a="http://schemas.openxmlformats.org/drawingml/2006/main">
+            <a:off x="685800" y="4705350"/>
+            <a:ext cx="10820400" cy="1047750"/>
+          </a:xfrm>
+          <a:prstGeom xmlns:a="http://schemas.openxmlformats.org/drawingml/2006/main" prst="rect">
+            <a:avLst/>
+          </a:prstGeom>
+          <a:solidFill xmlns:a="http://schemas.openxmlformats.org/drawingml/2006/main">
+            <a:srgbClr val="15334A"/>
+          </a:solidFill>
+        </p:spPr>
+        <p:txBody>
+          <a:bodyPr xmlns:a="http://schemas.openxmlformats.org/drawingml/2006/main"/>
+          <a:lstStyle xmlns:a="http://schemas.openxmlformats.org/drawingml/2006/main">
+            <a:defPPr algn="l">
+              <a:defRPr sz="1650" b="0">
+                <a:solidFill>
+                  <a:srgbClr val="243746"/>
+                </a:solidFill>
+                <a:latin typeface="Arial"/>
+                <a:ea typeface="Arial"/>
+                <a:cs typeface="Arial"/>
+              </a:defRPr>
+            </a:defPPr>
+            <a:lvl1pPr algn="l">
+              <a:defRPr sz="1650" b="0">
+                <a:solidFill>
+                  <a:srgbClr val="243746"/>
+                </a:solidFill>
+                <a:latin typeface="Arial"/>
+                <a:ea typeface="Arial"/>
+                <a:cs typeface="Arial"/>
+              </a:defRPr>
+            </a:lvl1pPr>
+            <a:lvl2pPr algn="l">
+              <a:defRPr sz="1650" b="0">
+                <a:solidFill>
+                  <a:srgbClr val="243746"/>
+                </a:solidFill>
+                <a:latin typeface="Arial"/>
+                <a:ea typeface="Arial"/>
+                <a:cs typeface="Arial"/>
+              </a:defRPr>
+            </a:lvl2pPr>
+            <a:lvl3pPr algn="l">
+              <a:defRPr sz="1650" b="0">
+                <a:solidFill>
+                  <a:srgbClr val="243746"/>
+                </a:solidFill>
+                <a:latin typeface="Arial"/>
+                <a:ea typeface="Arial"/>
+                <a:cs typeface="Arial"/>
+              </a:defRPr>
+            </a:lvl3pPr>
+            <a:lvl4pPr algn="l">
+              <a:defRPr sz="1650" b="0">
+                <a:solidFill>
+                  <a:srgbClr val="243746"/>
+                </a:solidFill>
+                <a:latin typeface="Arial"/>
+                <a:ea typeface="Arial"/>
+                <a:cs typeface="Arial"/>
+              </a:defRPr>
+            </a:lvl4pPr>
+            <a:lvl5pPr algn="l">
+              <a:defRPr sz="1650" b="0">
+                <a:solidFill>
+                  <a:srgbClr val="243746"/>
+                </a:solidFill>
+                <a:latin typeface="Arial"/>
+                <a:ea typeface="Arial"/>
+                <a:cs typeface="Arial"/>
+              </a:defRPr>
+            </a:lvl5pPr>
+            <a:lvl6pPr algn="l">
+              <a:defRPr sz="1650" b="0">
+                <a:solidFill>
+                  <a:srgbClr val="243746"/>
+                </a:solidFill>
+                <a:latin typeface="Arial"/>
+                <a:ea typeface="Arial"/>
+                <a:cs typeface="Arial"/>
+              </a:defRPr>
+            </a:lvl6pPr>
+            <a:lvl7pPr algn="l">
+              <a:defRPr sz="1650" b="0">
+                <a:solidFill>
+                  <a:srgbClr val="243746"/>
+                </a:solidFill>
+                <a:latin typeface="Arial"/>
+                <a:ea typeface="Arial"/>
+                <a:cs typeface="Arial"/>
+              </a:defRPr>
+            </a:lvl7pPr>
+            <a:lvl8pPr algn="l">
+              <a:defRPr sz="1650" b="0">
+                <a:solidFill>
+                  <a:srgbClr val="243746"/>
+                </a:solidFill>
+                <a:latin typeface="Arial"/>
+                <a:ea typeface="Arial"/>
+                <a:cs typeface="Arial"/>
+              </a:defRPr>
+            </a:lvl8pPr>
+            <a:lvl9pPr algn="l">
+              <a:defRPr sz="1650" b="0">
+                <a:solidFill>
+                  <a:srgbClr val="243746"/>
+                </a:solidFill>
+                <a:latin typeface="Arial"/>
+                <a:ea typeface="Arial"/>
+                <a:cs typeface="Arial"/>
+              </a:defRPr>
+            </a:lvl9pPr>
+          </a:lstStyle>
+          <a:p xmlns:a="http://schemas.openxmlformats.org/drawingml/2006/main">
+            <a:r>
+              <a:t/>
+            </a:r>
+          </a:p>
+        </p:txBody>
+      </p:sp>
+      <p:sp>
+        <p:nvSpPr>
+          <p:cNvPr id="16" name="investment-question-label">
+            <a:extLst xmlns:a="http://schemas.openxmlformats.org/drawingml/2006/main">
+              <a:ext uri="{FF2B5EF4-FFF2-40B4-BE49-F238E27FC236}">
+                <a16:creationId xmlns:a16="http://schemas.microsoft.com/office/drawing/2014/main" id="{3E38DFA0-0F8F-49B5-9AA6-C7500CFFDBBB}"/>
+              </a:ext>
+            </a:extLst>
+          </p:cNvPr>
+          <p:cNvSpPr>
+            <a:spLocks xmlns:a="http://schemas.openxmlformats.org/drawingml/2006/main" noGrp="1"/>
+          </p:cNvSpPr>
+          <p:nvPr/>
+        </p:nvSpPr>
+        <p:spPr>
+          <a:xfrm xmlns:a="http://schemas.openxmlformats.org/drawingml/2006/main">
+            <a:off x="914400" y="4914900"/>
+            <a:ext cx="2476500" cy="266700"/>
+          </a:xfrm>
+          <a:prstGeom xmlns:a="http://schemas.openxmlformats.org/drawingml/2006/main" prst="rect">
+            <a:avLst/>
+          </a:prstGeom>
+          <a:noFill xmlns:a="http://schemas.openxmlformats.org/drawingml/2006/main"/>
+        </p:spPr>
+        <p:txBody>
+          <a:bodyPr xmlns:a="http://schemas.openxmlformats.org/drawingml/2006/main" lIns="0" tIns="0" rIns="0" bIns="0"/>
+          <a:lstStyle xmlns:a="http://schemas.openxmlformats.org/drawingml/2006/main">
+            <a:defPPr algn="l">
+              <a:defRPr sz="1350" b="1">
+                <a:solidFill>
+                  <a:srgbClr val="B9D8D2"/>
+                </a:solidFill>
+                <a:latin typeface="Arial"/>
+                <a:ea typeface="Arial"/>
+                <a:cs typeface="Arial"/>
+              </a:defRPr>
+            </a:defPPr>
+            <a:lvl1pPr algn="l">
+              <a:defRPr sz="1350" b="1">
+                <a:solidFill>
+                  <a:srgbClr val="B9D8D2"/>
+                </a:solidFill>
+                <a:latin typeface="Arial"/>
+                <a:ea typeface="Arial"/>
+                <a:cs typeface="Arial"/>
+              </a:defRPr>
+            </a:lvl1pPr>
+            <a:lvl2pPr algn="l">
+              <a:defRPr sz="1350" b="1">
+                <a:solidFill>
+                  <a:srgbClr val="B9D8D2"/>
+                </a:solidFill>
+                <a:latin typeface="Arial"/>
+                <a:ea typeface="Arial"/>
+                <a:cs typeface="Arial"/>
+              </a:defRPr>
+            </a:lvl2pPr>
+            <a:lvl3pPr algn="l">
+              <a:defRPr sz="1350" b="1">
+                <a:solidFill>
+                  <a:srgbClr val="B9D8D2"/>
+                </a:solidFill>
+                <a:latin typeface="Arial"/>
+                <a:ea typeface="Arial"/>
+                <a:cs typeface="Arial"/>
+              </a:defRPr>
+            </a:lvl3pPr>
+            <a:lvl4pPr algn="l">
+              <a:defRPr sz="1350" b="1">
+                <a:solidFill>
+                  <a:srgbClr val="B9D8D2"/>
+                </a:solidFill>
+                <a:latin typeface="Arial"/>
+                <a:ea typeface="Arial"/>
+                <a:cs typeface="Arial"/>
+              </a:defRPr>
+            </a:lvl4pPr>
+            <a:lvl5pPr algn="l">
+              <a:defRPr sz="1350" b="1">
+                <a:solidFill>
+                  <a:srgbClr val="B9D8D2"/>
+                </a:solidFill>
+                <a:latin typeface="Arial"/>
+                <a:ea typeface="Arial"/>
+                <a:cs typeface="Arial"/>
+              </a:defRPr>
+            </a:lvl5pPr>
+            <a:lvl6pPr algn="l">
+              <a:defRPr sz="1350" b="1">
+                <a:solidFill>
+                  <a:srgbClr val="B9D8D2"/>
+                </a:solidFill>
+                <a:latin typeface="Arial"/>
+                <a:ea typeface="Arial"/>
+                <a:cs typeface="Arial"/>
+              </a:defRPr>
+            </a:lvl6pPr>
+            <a:lvl7pPr algn="l">
+              <a:defRPr sz="1350" b="1">
+                <a:solidFill>
+                  <a:srgbClr val="B9D8D2"/>
+                </a:solidFill>
+                <a:latin typeface="Arial"/>
+                <a:ea typeface="Arial"/>
+                <a:cs typeface="Arial"/>
+              </a:defRPr>
+            </a:lvl7pPr>
+            <a:lvl8pPr algn="l">
+              <a:defRPr sz="1350" b="1">
+                <a:solidFill>
+                  <a:srgbClr val="B9D8D2"/>
+                </a:solidFill>
+                <a:latin typeface="Arial"/>
+                <a:ea typeface="Arial"/>
+                <a:cs typeface="Arial"/>
+              </a:defRPr>
+            </a:lvl8pPr>
+            <a:lvl9pPr algn="l">
+              <a:defRPr sz="1350" b="1">
+                <a:solidFill>
+                  <a:srgbClr val="B9D8D2"/>
+                </a:solidFill>
+                <a:latin typeface="Arial"/>
+                <a:ea typeface="Arial"/>
+                <a:cs typeface="Arial"/>
+              </a:defRPr>
+            </a:lvl9pPr>
+          </a:lstStyle>
+          <a:p xmlns:a="http://schemas.openxmlformats.org/drawingml/2006/main">
+            <a:pPr algn="l">
+              <a:defRPr sz="1350" b="1">
+                <a:solidFill>
+                  <a:srgbClr val="B9D8D2"/>
+                </a:solidFill>
+                <a:latin typeface="Arial"/>
+                <a:ea typeface="Arial"/>
+                <a:cs typeface="Arial"/>
+              </a:defRPr>
+            </a:pPr>
+            <a:r>
+              <a:rPr sz="1350" b="1">
+                <a:solidFill>
+                  <a:srgbClr val="B9D8D2"/>
+                </a:solidFill>
+                <a:latin typeface="Arial"/>
+                <a:ea typeface="Arial"/>
+                <a:cs typeface="Arial"/>
+              </a:rPr>
+              <a:t>COMMITTEE QUESTION</a:t>
+            </a:r>
+          </a:p>
+        </p:txBody>
+      </p:sp>
+      <p:sp>
+        <p:nvSpPr>
+          <p:cNvPr id="17" name="investment-question">
+            <a:extLst xmlns:a="http://schemas.openxmlformats.org/drawingml/2006/main">
+              <a:ext uri="{FF2B5EF4-FFF2-40B4-BE49-F238E27FC236}">
+                <a16:creationId xmlns:a16="http://schemas.microsoft.com/office/drawing/2014/main" id="{6FD4E8AD-13D0-4420-AF9D-904D8E6DB876}"/>
+              </a:ext>
+            </a:extLst>
+          </p:cNvPr>
+          <p:cNvSpPr>
+            <a:spLocks xmlns:a="http://schemas.openxmlformats.org/drawingml/2006/main" noGrp="1"/>
+          </p:cNvSpPr>
+          <p:nvPr/>
+        </p:nvSpPr>
+        <p:spPr>
+          <a:xfrm xmlns:a="http://schemas.openxmlformats.org/drawingml/2006/main">
+            <a:off x="914400" y="5257800"/>
+            <a:ext cx="10287000" cy="323850"/>
+          </a:xfrm>
+          <a:prstGeom xmlns:a="http://schemas.openxmlformats.org/drawingml/2006/main" prst="rect">
+            <a:avLst/>
+          </a:prstGeom>
+          <a:noFill xmlns:a="http://schemas.openxmlformats.org/drawingml/2006/main"/>
+        </p:spPr>
+        <p:txBody>
+          <a:bodyPr xmlns:a="http://schemas.openxmlformats.org/drawingml/2006/main" lIns="0" tIns="0" rIns="0" bIns="0"/>
+          <a:lstStyle xmlns:a="http://schemas.openxmlformats.org/drawingml/2006/main">
+            <a:defPPr algn="l">
+              <a:defRPr sz="1875" b="1">
+                <a:solidFill>
+                  <a:srgbClr val="FFFFFF"/>
+                </a:solidFill>
+                <a:latin typeface="Arial"/>
+                <a:ea typeface="Arial"/>
+                <a:cs typeface="Arial"/>
+              </a:defRPr>
+            </a:defPPr>
+            <a:lvl1pPr algn="l">
+              <a:defRPr sz="1875" b="1">
+                <a:solidFill>
+                  <a:srgbClr val="FFFFFF"/>
+                </a:solidFill>
+                <a:latin typeface="Arial"/>
+                <a:ea typeface="Arial"/>
+                <a:cs typeface="Arial"/>
+              </a:defRPr>
+            </a:lvl1pPr>
+            <a:lvl2pPr algn="l">
+              <a:defRPr sz="1875" b="1">
+                <a:solidFill>
+                  <a:srgbClr val="FFFFFF"/>
+                </a:solidFill>
+                <a:latin typeface="Arial"/>
+                <a:ea typeface="Arial"/>
+                <a:cs typeface="Arial"/>
+              </a:defRPr>
+            </a:lvl2pPr>
+            <a:lvl3pPr algn="l">
+              <a:defRPr sz="1875" b="1">
+                <a:solidFill>
+                  <a:srgbClr val="FFFFFF"/>
+                </a:solidFill>
+                <a:latin typeface="Arial"/>
+                <a:ea typeface="Arial"/>
+                <a:cs typeface="Arial"/>
+              </a:defRPr>
+            </a:lvl3pPr>
+            <a:lvl4pPr algn="l">
+              <a:defRPr sz="1875" b="1">
+                <a:solidFill>
+                  <a:srgbClr val="FFFFFF"/>
+                </a:solidFill>
+                <a:latin typeface="Arial"/>
+                <a:ea typeface="Arial"/>
+                <a:cs typeface="Arial"/>
+              </a:defRPr>
+            </a:lvl4pPr>
+            <a:lvl5pPr algn="l">
+              <a:defRPr sz="1875" b="1">
+                <a:solidFill>
+                  <a:srgbClr val="FFFFFF"/>
+                </a:solidFill>
+                <a:latin typeface="Arial"/>
+                <a:ea typeface="Arial"/>
+                <a:cs typeface="Arial"/>
+              </a:defRPr>
+            </a:lvl5pPr>
+            <a:lvl6pPr algn="l">
+              <a:defRPr sz="1875" b="1">
+                <a:solidFill>
+                  <a:srgbClr val="FFFFFF"/>
+                </a:solidFill>
+                <a:latin typeface="Arial"/>
+                <a:ea typeface="Arial"/>
+                <a:cs typeface="Arial"/>
+              </a:defRPr>
+            </a:lvl6pPr>
+            <a:lvl7pPr algn="l">
+              <a:defRPr sz="1875" b="1">
+                <a:solidFill>
+                  <a:srgbClr val="FFFFFF"/>
+                </a:solidFill>
+                <a:latin typeface="Arial"/>
+                <a:ea typeface="Arial"/>
+                <a:cs typeface="Arial"/>
+              </a:defRPr>
+            </a:lvl7pPr>
+            <a:lvl8pPr algn="l">
+              <a:defRPr sz="1875" b="1">
+                <a:solidFill>
+                  <a:srgbClr val="FFFFFF"/>
+                </a:solidFill>
+                <a:latin typeface="Arial"/>
+                <a:ea typeface="Arial"/>
+                <a:cs typeface="Arial"/>
+              </a:defRPr>
+            </a:lvl8pPr>
+            <a:lvl9pPr algn="l">
+              <a:defRPr sz="1875" b="1">
+                <a:solidFill>
+                  <a:srgbClr val="FFFFFF"/>
+                </a:solidFill>
+                <a:latin typeface="Arial"/>
+                <a:ea typeface="Arial"/>
+                <a:cs typeface="Arial"/>
+              </a:defRPr>
+            </a:lvl9pPr>
+          </a:lstStyle>
+          <a:p xmlns:a="http://schemas.openxmlformats.org/drawingml/2006/main">
+            <a:pPr algn="l">
+              <a:defRPr sz="1875" b="1">
+                <a:solidFill>
+                  <a:srgbClr val="FFFFFF"/>
+                </a:solidFill>
+                <a:latin typeface="Arial"/>
+                <a:ea typeface="Arial"/>
+                <a:cs typeface="Arial"/>
+              </a:defRPr>
+            </a:pPr>
+            <a:r>
+              <a:rPr sz="1875" b="1">
+                <a:solidFill>
+                  <a:srgbClr val="FFFFFF"/>
+                </a:solidFill>
+                <a:latin typeface="Arial"/>
+                <a:ea typeface="Arial"/>
+                <a:cs typeface="Arial"/>
+              </a:rPr>
+              <a:t>Do the records support investing $500,000 in the next phase of growth?</a:t>
+            </a:r>
+          </a:p>
+        </p:txBody>
+      </p:sp>
+      <p:sp>
+        <p:nvSpPr>
+          <p:cNvPr id="18" name="case-source">
+            <a:extLst xmlns:a="http://schemas.openxmlformats.org/drawingml/2006/main">
+              <a:ext uri="{FF2B5EF4-FFF2-40B4-BE49-F238E27FC236}">
+                <a16:creationId xmlns:a16="http://schemas.microsoft.com/office/drawing/2014/main" id="{C15C18C1-2CC2-4018-A3A5-634011A0717B}"/>
+              </a:ext>
+            </a:extLst>
+          </p:cNvPr>
+          <p:cNvSpPr>
+            <a:spLocks xmlns:a="http://schemas.openxmlformats.org/drawingml/2006/main" noGrp="1"/>
+          </p:cNvSpPr>
+          <p:nvPr/>
+        </p:nvSpPr>
+        <p:spPr>
+          <a:xfrm xmlns:a="http://schemas.openxmlformats.org/drawingml/2006/main">
+            <a:off x="685800" y="6419850"/>
+            <a:ext cx="10001250" cy="209550"/>
+          </a:xfrm>
+          <a:prstGeom xmlns:a="http://schemas.openxmlformats.org/drawingml/2006/main" prst="rect">
+            <a:avLst/>
+          </a:prstGeom>
+          <a:noFill xmlns:a="http://schemas.openxmlformats.org/drawingml/2006/main"/>
+        </p:spPr>
+        <p:txBody>
+          <a:bodyPr xmlns:a="http://schemas.openxmlformats.org/drawingml/2006/main" lIns="0" tIns="0" rIns="0" bIns="0"/>
+          <a:lstStyle xmlns:a="http://schemas.openxmlformats.org/drawingml/2006/main">
+            <a:defPPr algn="l">
+              <a:defRPr sz="1125" b="0">
+                <a:solidFill>
+                  <a:srgbClr val="526676"/>
+                </a:solidFill>
+                <a:latin typeface="Arial"/>
+                <a:ea typeface="Arial"/>
+                <a:cs typeface="Arial"/>
+              </a:defRPr>
+            </a:defPPr>
+            <a:lvl1pPr algn="l">
+              <a:defRPr sz="1125" b="0">
+                <a:solidFill>
+                  <a:srgbClr val="526676"/>
+                </a:solidFill>
+                <a:latin typeface="Arial"/>
+                <a:ea typeface="Arial"/>
+                <a:cs typeface="Arial"/>
+              </a:defRPr>
+            </a:lvl1pPr>
+            <a:lvl2pPr algn="l">
+              <a:defRPr sz="1125" b="0">
+                <a:solidFill>
+                  <a:srgbClr val="526676"/>
+                </a:solidFill>
+                <a:latin typeface="Arial"/>
+                <a:ea typeface="Arial"/>
+                <a:cs typeface="Arial"/>
+              </a:defRPr>
+            </a:lvl2pPr>
+            <a:lvl3pPr algn="l">
+              <a:defRPr sz="1125" b="0">
+                <a:solidFill>
+                  <a:srgbClr val="526676"/>
+                </a:solidFill>
+                <a:latin typeface="Arial"/>
+                <a:ea typeface="Arial"/>
+                <a:cs typeface="Arial"/>
+              </a:defRPr>
+            </a:lvl3pPr>
+            <a:lvl4pPr algn="l">
+              <a:defRPr sz="1125" b="0">
+                <a:solidFill>
+                  <a:srgbClr val="526676"/>
+                </a:solidFill>
+                <a:latin typeface="Arial"/>
+                <a:ea typeface="Arial"/>
+                <a:cs typeface="Arial"/>
+              </a:defRPr>
+            </a:lvl4pPr>
+            <a:lvl5pPr algn="l">
+              <a:defRPr sz="1125" b="0">
+                <a:solidFill>
+                  <a:srgbClr val="526676"/>
+                </a:solidFill>
+                <a:latin typeface="Arial"/>
+                <a:ea typeface="Arial"/>
+                <a:cs typeface="Arial"/>
+              </a:defRPr>
+            </a:lvl5pPr>
+            <a:lvl6pPr algn="l">
+              <a:defRPr sz="1125" b="0">
+                <a:solidFill>
+                  <a:srgbClr val="526676"/>
+                </a:solidFill>
+                <a:latin typeface="Arial"/>
+                <a:ea typeface="Arial"/>
+                <a:cs typeface="Arial"/>
+              </a:defRPr>
+            </a:lvl6pPr>
+            <a:lvl7pPr algn="l">
+              <a:defRPr sz="1125" b="0">
+                <a:solidFill>
+                  <a:srgbClr val="526676"/>
+                </a:solidFill>
+                <a:latin typeface="Arial"/>
+                <a:ea typeface="Arial"/>
+                <a:cs typeface="Arial"/>
+              </a:defRPr>
+            </a:lvl7pPr>
+            <a:lvl8pPr algn="l">
+              <a:defRPr sz="1125" b="0">
+                <a:solidFill>
+                  <a:srgbClr val="526676"/>
+                </a:solidFill>
+                <a:latin typeface="Arial"/>
+                <a:ea typeface="Arial"/>
+                <a:cs typeface="Arial"/>
+              </a:defRPr>
+            </a:lvl8pPr>
+            <a:lvl9pPr algn="l">
+              <a:defRPr sz="1125" b="0">
+                <a:solidFill>
+                  <a:srgbClr val="526676"/>
+                </a:solidFill>
+                <a:latin typeface="Arial"/>
+                <a:ea typeface="Arial"/>
+                <a:cs typeface="Arial"/>
+              </a:defRPr>
+            </a:lvl9pPr>
+          </a:lstStyle>
+          <a:p xmlns:a="http://schemas.openxmlformats.org/drawingml/2006/main">
+            <a:pPr algn="l">
+              <a:defRPr sz="1125" b="0">
+                <a:solidFill>
+                  <a:srgbClr val="526676"/>
+                </a:solidFill>
+                <a:latin typeface="Arial"/>
+                <a:ea typeface="Arial"/>
+                <a:cs typeface="Arial"/>
+              </a:defRPr>
+            </a:pPr>
+            <a:r>
+              <a:rPr sz="1125" b="0">
+                <a:solidFill>
+                  <a:srgbClr val="526676"/>
+                </a:solidFill>
+                <a:latin typeface="Arial"/>
+                <a:ea typeface="Arial"/>
+                <a:cs typeface="Arial"/>
+              </a:rPr>
+              <a:t>Source: inputs/claims.md | Management figures shown as stated in the case brief</a:t>
+            </a:r>
+          </a:p>
+        </p:txBody>
+      </p:sp>
+      <p:sp>
+        <p:nvSpPr>
+          <p:cNvPr id="19" name="page-number">
+            <a:extLst xmlns:a="http://schemas.openxmlformats.org/drawingml/2006/main">
+              <a:ext uri="{FF2B5EF4-FFF2-40B4-BE49-F238E27FC236}">
+                <a16:creationId xmlns:a16="http://schemas.microsoft.com/office/drawing/2014/main" id="{FF646214-31A8-4026-B993-A39457D449EC}"/>
+              </a:ext>
+            </a:extLst>
+          </p:cNvPr>
+          <p:cNvSpPr>
+            <a:spLocks xmlns:a="http://schemas.openxmlformats.org/drawingml/2006/main" noGrp="1"/>
+          </p:cNvSpPr>
+          <p:nvPr/>
+        </p:nvSpPr>
+        <p:spPr>
+          <a:xfrm xmlns:a="http://schemas.openxmlformats.org/drawingml/2006/main">
+            <a:off x="11277600" y="6438900"/>
+            <a:ext cx="304800" cy="209550"/>
+          </a:xfrm>
+          <a:prstGeom xmlns:a="http://schemas.openxmlformats.org/drawingml/2006/main" prst="rect">
+            <a:avLst/>
+          </a:prstGeom>
+          <a:noFill xmlns:a="http://schemas.openxmlformats.org/drawingml/2006/main"/>
+        </p:spPr>
+        <p:txBody>
+          <a:bodyPr xmlns:a="http://schemas.openxmlformats.org/drawingml/2006/main" lIns="0" tIns="0" rIns="0" bIns="0"/>
+          <a:lstStyle xmlns:a="http://schemas.openxmlformats.org/drawingml/2006/main">
+            <a:defPPr algn="r">
+              <a:defRPr sz="1125" b="0">
+                <a:solidFill>
+                  <a:srgbClr val="526676"/>
+                </a:solidFill>
+                <a:latin typeface="Arial"/>
+                <a:ea typeface="Arial"/>
+                <a:cs typeface="Arial"/>
+              </a:defRPr>
+            </a:defPPr>
+            <a:lvl1pPr algn="r">
+              <a:defRPr sz="1125" b="0">
+                <a:solidFill>
+                  <a:srgbClr val="526676"/>
+                </a:solidFill>
+                <a:latin typeface="Arial"/>
+                <a:ea typeface="Arial"/>
+                <a:cs typeface="Arial"/>
+              </a:defRPr>
+            </a:lvl1pPr>
+            <a:lvl2pPr algn="r">
+              <a:defRPr sz="1125" b="0">
+                <a:solidFill>
+                  <a:srgbClr val="526676"/>
+                </a:solidFill>
+                <a:latin typeface="Arial"/>
+                <a:ea typeface="Arial"/>
+                <a:cs typeface="Arial"/>
+              </a:defRPr>
+            </a:lvl2pPr>
+            <a:lvl3pPr algn="r">
+              <a:defRPr sz="1125" b="0">
+                <a:solidFill>
+                  <a:srgbClr val="526676"/>
+                </a:solidFill>
+                <a:latin typeface="Arial"/>
+                <a:ea typeface="Arial"/>
+                <a:cs typeface="Arial"/>
+              </a:defRPr>
+            </a:lvl3pPr>
+            <a:lvl4pPr algn="r">
+              <a:defRPr sz="1125" b="0">
+                <a:solidFill>
+                  <a:srgbClr val="526676"/>
+                </a:solidFill>
+                <a:latin typeface="Arial"/>
+                <a:ea typeface="Arial"/>
+                <a:cs typeface="Arial"/>
+              </a:defRPr>
+            </a:lvl4pPr>
+            <a:lvl5pPr algn="r">
+              <a:defRPr sz="1125" b="0">
+                <a:solidFill>
+                  <a:srgbClr val="526676"/>
+                </a:solidFill>
+                <a:latin typeface="Arial"/>
+                <a:ea typeface="Arial"/>
+                <a:cs typeface="Arial"/>
+              </a:defRPr>
+            </a:lvl5pPr>
+            <a:lvl6pPr algn="r">
+              <a:defRPr sz="1125" b="0">
+                <a:solidFill>
+                  <a:srgbClr val="526676"/>
+                </a:solidFill>
+                <a:latin typeface="Arial"/>
+                <a:ea typeface="Arial"/>
+                <a:cs typeface="Arial"/>
+              </a:defRPr>
+            </a:lvl6pPr>
+            <a:lvl7pPr algn="r">
+              <a:defRPr sz="1125" b="0">
+                <a:solidFill>
+                  <a:srgbClr val="526676"/>
+                </a:solidFill>
+                <a:latin typeface="Arial"/>
+                <a:ea typeface="Arial"/>
+                <a:cs typeface="Arial"/>
+              </a:defRPr>
+            </a:lvl7pPr>
+            <a:lvl8pPr algn="r">
+              <a:defRPr sz="1125" b="0">
+                <a:solidFill>
+                  <a:srgbClr val="526676"/>
+                </a:solidFill>
+                <a:latin typeface="Arial"/>
+                <a:ea typeface="Arial"/>
+                <a:cs typeface="Arial"/>
+              </a:defRPr>
+            </a:lvl8pPr>
+            <a:lvl9pPr algn="r">
+              <a:defRPr sz="1125" b="0">
+                <a:solidFill>
+                  <a:srgbClr val="526676"/>
+                </a:solidFill>
+                <a:latin typeface="Arial"/>
+                <a:ea typeface="Arial"/>
+                <a:cs typeface="Arial"/>
+              </a:defRPr>
+            </a:lvl9pPr>
+          </a:lstStyle>
+          <a:p xmlns:a="http://schemas.openxmlformats.org/drawingml/2006/main">
+            <a:pPr algn="r">
+              <a:defRPr sz="1125" b="0">
+                <a:solidFill>
+                  <a:srgbClr val="526676"/>
+                </a:solidFill>
+                <a:latin typeface="Arial"/>
+                <a:ea typeface="Arial"/>
+                <a:cs typeface="Arial"/>
+              </a:defRPr>
+            </a:pPr>
+            <a:r>
+              <a:rPr sz="1125" b="0">
+                <a:solidFill>
+                  <a:srgbClr val="526676"/>
+                </a:solidFill>
+                <a:latin typeface="Arial"/>
+                <a:ea typeface="Arial"/>
+                <a:cs typeface="Arial"/>
+              </a:rPr>
+              <a:t>1</a:t>
+            </a:r>
+          </a:p>
+        </p:txBody>
+      </p:sp>
+    </p:spTree>
+    <p:extLst>
+      <p:ext uri="{BB962C8B-B14F-4D97-AF65-F5344CB8AC3E}">
+        <p14:creationId xmlns:p14="http://schemas.microsoft.com/office/powerpoint/2010/main" val="413742151"/>
+      </p:ext>
+    </p:extLst>
+  </p:cSld>
+</p:sld>
+</file>
+
+<file path=ppt/slides/slide2.xml><?xml version="1.0" encoding="utf-8"?>
+<p:sld xmlns:p="http://schemas.openxmlformats.org/presentationml/2006/main">
+  <p:cSld>
+    <p:bg>
+      <p:bgPr>
+        <a:solidFill xmlns:a="http://schemas.openxmlformats.org/drawingml/2006/main">
+          <a:srgbClr val="FFFFFF"/>
+        </a:solidFill>
+      </p:bgPr>
+    </p:bg>
+    <p:spTree>
+      <p:nvGrpSpPr>
+        <p:cNvPr id="1" name=""/>
+        <p:cNvGrpSpPr/>
+        <p:nvPr/>
+      </p:nvGrpSpPr>
+      <p:grpSpPr>
+        <a:xfrm xmlns:a="http://schemas.openxmlformats.org/drawingml/2006/main"/>
+      </p:grpSpPr>
+      <p:sp>
+        <p:nvSpPr>
           <p:cNvPr id="11" name="cover-title">
             <a:extLst xmlns:a="http://schemas.openxmlformats.org/drawingml/2006/main">
               <a:ext uri="{FF2B5EF4-FFF2-40B4-BE49-F238E27FC236}">
@@ -5733,7 +8766,7 @@
 </p:sld>
 </file>
 
-<file path=ppt/slides/slide2.xml><?xml version="1.0" encoding="utf-8"?>
+<file path=ppt/slides/slide3.xml><?xml version="1.0" encoding="utf-8"?>
 <p:sld xmlns:p="http://schemas.openxmlformats.org/presentationml/2006/main">
   <p:cSld>
     <p:bg>
@@ -6013,7 +9046,7 @@
                   <a:srgbClr val="526676"/>
                 </a:solidFill>
               </a:rPr>
-              <a:t>2</a:t>
+              <a:t>3</a:t>
             </a:r>
           </a:p>
         </p:txBody>
@@ -6156,7 +9189,7 @@
           <p:cNvPr id="4" name="">
             <a:extLst xmlns:a="http://schemas.openxmlformats.org/drawingml/2006/main">
               <a:ext uri="{FF2B5EF4-FFF2-40B4-BE49-F238E27FC236}">
-                <a16:creationId xmlns:a16="http://schemas.microsoft.com/office/drawing/2014/main" id="{73088A7E-6F1D-4200-90C2-A3A2D9F2B2D1}"/>
+                <a16:creationId xmlns:a16="http://schemas.microsoft.com/office/drawing/2014/main" id="{16DA3479-FE0C-4A9A-9640-27FA69694D51}"/>
               </a:ext>
             </a:extLst>
           </p:cNvPr>
@@ -7139,7 +10172,7 @@
 </p:sld>
 </file>
 
-<file path=ppt/slides/slide3.xml><?xml version="1.0" encoding="utf-8"?>
+<file path=ppt/slides/slide4.xml><?xml version="1.0" encoding="utf-8"?>
 <p:sld xmlns:p="http://schemas.openxmlformats.org/presentationml/2006/main">
   <p:cSld>
     <p:bg>
@@ -7419,7 +10452,7 @@
                   <a:srgbClr val="526676"/>
                 </a:solidFill>
               </a:rPr>
-              <a:t>3</a:t>
+              <a:t>4</a:t>
             </a:r>
           </a:p>
         </p:txBody>
@@ -7695,7 +10728,7 @@
           <p:cNvPr id="5" name="">
             <a:extLst xmlns:a="http://schemas.openxmlformats.org/drawingml/2006/main">
               <a:ext uri="{FF2B5EF4-FFF2-40B4-BE49-F238E27FC236}">
-                <a16:creationId xmlns:a16="http://schemas.microsoft.com/office/drawing/2014/main" id="{172510A9-3AA7-46EA-9ED4-95C0781437E5}"/>
+                <a16:creationId xmlns:a16="http://schemas.microsoft.com/office/drawing/2014/main" id="{549C7FD7-B5F2-459D-B26C-FA63D66E7534}"/>
               </a:ext>
             </a:extLst>
           </p:cNvPr>
@@ -8426,7 +11459,7 @@
 </p:sld>
 </file>
 
-<file path=ppt/slides/slide4.xml><?xml version="1.0" encoding="utf-8"?>
+<file path=ppt/slides/slide5.xml><?xml version="1.0" encoding="utf-8"?>
 <p:sld xmlns:p="http://schemas.openxmlformats.org/presentationml/2006/main">
   <p:cSld>
     <p:bg>
@@ -8706,7 +11739,7 @@
                   <a:srgbClr val="526676"/>
                 </a:solidFill>
               </a:rPr>
-              <a:t>4</a:t>
+              <a:t>5</a:t>
             </a:r>
           </a:p>
         </p:txBody>
@@ -9248,7 +12281,7 @@
           <p:cNvPr id="9" name="Chart">
             <a:extLst xmlns:a="http://schemas.openxmlformats.org/drawingml/2006/main">
               <a:ext uri="{FF2B5EF4-FFF2-40B4-BE49-F238E27FC236}">
-                <a16:creationId xmlns:a16="http://schemas.microsoft.com/office/drawing/2014/main" id="{0D7D0C58-1818-4893-8D71-EF3642EAD6E1}"/>
+                <a16:creationId xmlns:a16="http://schemas.microsoft.com/office/drawing/2014/main" id="{C7663220-9B28-4983-A92B-43AF03BBA14E}"/>
               </a:ext>
             </a:extLst>
           </p:cNvPr>
@@ -9261,7 +12294,7 @@
         </p:xfrm>
         <a:graphic xmlns:a="http://schemas.openxmlformats.org/drawingml/2006/main">
           <a:graphicData uri="http://schemas.openxmlformats.org/drawingml/2006/chart">
-            <c:chart xmlns:r="http://schemas.openxmlformats.org/officeDocument/2006/relationships" xmlns:c="http://schemas.openxmlformats.org/drawingml/2006/chart" r:id="R3584230f11694224"/>
+            <c:chart xmlns:r="http://schemas.openxmlformats.org/officeDocument/2006/relationships" xmlns:c="http://schemas.openxmlformats.org/drawingml/2006/chart" r:id="Rfe419065f133445e"/>
           </a:graphicData>
         </a:graphic>
       </p:graphicFrame>
@@ -9275,7 +12308,7 @@
 </p:sld>
 </file>
 
-<file path=ppt/slides/slide5.xml><?xml version="1.0" encoding="utf-8"?>
+<file path=ppt/slides/slide6.xml><?xml version="1.0" encoding="utf-8"?>
 <p:sld xmlns:p="http://schemas.openxmlformats.org/presentationml/2006/main">
   <p:cSld>
     <p:bg>
@@ -9555,7 +12588,7 @@
                   <a:srgbClr val="526676"/>
                 </a:solidFill>
               </a:rPr>
-              <a:t>5</a:t>
+              <a:t>6</a:t>
             </a:r>
           </a:p>
         </p:txBody>
@@ -9964,7 +12997,7 @@
           <p:cNvPr id="8" name="Chart">
             <a:extLst xmlns:a="http://schemas.openxmlformats.org/drawingml/2006/main">
               <a:ext uri="{FF2B5EF4-FFF2-40B4-BE49-F238E27FC236}">
-                <a16:creationId xmlns:a16="http://schemas.microsoft.com/office/drawing/2014/main" id="{47E3258D-1CDF-4B05-8984-DDDC96852F94}"/>
+                <a16:creationId xmlns:a16="http://schemas.microsoft.com/office/drawing/2014/main" id="{F0C2F20B-2564-46DA-B18F-A313B003309E}"/>
               </a:ext>
             </a:extLst>
           </p:cNvPr>
@@ -9977,7 +13010,7 @@
         </p:xfrm>
         <a:graphic xmlns:a="http://schemas.openxmlformats.org/drawingml/2006/main">
           <a:graphicData uri="http://schemas.openxmlformats.org/drawingml/2006/chart">
-            <c:chart xmlns:r="http://schemas.openxmlformats.org/officeDocument/2006/relationships" xmlns:c="http://schemas.openxmlformats.org/drawingml/2006/chart" r:id="R1c290ad4fc4e4e62"/>
+            <c:chart xmlns:r="http://schemas.openxmlformats.org/officeDocument/2006/relationships" xmlns:c="http://schemas.openxmlformats.org/drawingml/2006/chart" r:id="R2a1c82de4be84b1d"/>
           </a:graphicData>
         </a:graphic>
       </p:graphicFrame>
@@ -9991,7 +13024,7 @@
 </p:sld>
 </file>
 
-<file path=ppt/slides/slide6.xml><?xml version="1.0" encoding="utf-8"?>
+<file path=ppt/slides/slide7.xml><?xml version="1.0" encoding="utf-8"?>
 <p:sld xmlns:p="http://schemas.openxmlformats.org/presentationml/2006/main">
   <p:cSld>
     <p:bg>
@@ -10271,7 +13304,7 @@
                   <a:srgbClr val="526676"/>
                 </a:solidFill>
               </a:rPr>
-              <a:t>6</a:t>
+              <a:t>7</a:t>
             </a:r>
           </a:p>
         </p:txBody>

</xml_diff>